<commit_message>
docs: drop week estimates from the use-case deck
The roadmap now shows the four phases in order, then the pilot with a
partner site, with no durations; the speaker notes lose the week
figures and the left-bag alert note just calls it optional.
</commit_message>
<xml_diff>
--- a/docs/deck/arabic-video-search-use-cases.pptx
+++ b/docs/deck/arabic-video-search-use-cases.pptx
@@ -888,27 +888,27 @@
           <a:lstStyle/>
           <a:p>
             <a:r>
-              <a:t>Timeline estimate, about 9 weeks (report section 6):</a:t>
-            </a:r>
-          </a:p>
-          <a:p>
-            <a:r>
-              <a:t>Phase 0 set-up, week 1: Mac set up, clips downloaded and trimmed, ground truth written.</a:t>
-            </a:r>
-          </a:p>
-          <a:p>
-            <a:r>
-              <a:t>Phase 1 baseline with option A (direct multilingual embedding), weeks 2-4.</a:t>
-            </a:r>
-          </a:p>
-          <a:p>
-            <a:r>
-              <a:t>Phase 2 Arabic hybrid (query parser, attributes, double-check), weeks 5-7.</a:t>
-            </a:r>
-          </a:p>
-          <a:p>
-            <a:r>
-              <a:t>Phase 3 demo-ready, weeks 8-9.</a:t>
+              <a:t>Phases, in order (report section 6); no time estimates are given here:</a:t>
+            </a:r>
+          </a:p>
+          <a:p>
+            <a:r>
+              <a:t>Phase 0 set-up: Mac set up, clips downloaded and trimmed, ground truth written.</a:t>
+            </a:r>
+          </a:p>
+          <a:p>
+            <a:r>
+              <a:t>Phase 1 baseline with option A (direct multilingual embedding).</a:t>
+            </a:r>
+          </a:p>
+          <a:p>
+            <a:r>
+              <a:t>Phase 2 Arabic hybrid (query parser, attributes, double-check).</a:t>
+            </a:r>
+          </a:p>
+          <a:p>
+            <a:r>
+              <a:t>Phase 3 demo-ready.</a:t>
             </a:r>
           </a:p>
           <a:p>
@@ -1398,7 +1398,7 @@
           </a:p>
           <a:p>
             <a:r>
-              <a:t>An automatic left-bag alert (owner walks away, bag stays) is a separate, optional feature of about 1-2 extra weeks; it is not part of the PoC (report D6 answer).</a:t>
+              <a:t>An automatic left-bag alert (owner walks away, bag stays) is a separate, optional feature and is not part of the PoC (report D6 answer).</a:t>
             </a:r>
           </a:p>
           <a:p>
@@ -13181,7 +13181,7 @@
                 <a:ea typeface="Aptos"/>
                 <a:cs typeface="Dubai"/>
               </a:rPr>
-              <a:t>About 9 weeks to a working demo, then a pilot with a partner site</a:t>
+              <a:t>Four phases to a working demo, then a pilot with a partner site</a:t>
             </a:r>
           </a:p>
         </p:txBody>
@@ -13195,7 +13195,7 @@
         <p:spPr>
           <a:xfrm>
             <a:off x="548640" y="1783080"/>
-            <a:ext cx="1208024" cy="566928"/>
+            <a:ext cx="2635758" cy="566928"/>
           </a:xfrm>
           <a:prstGeom prst="roundRect">
             <a:avLst>
@@ -13239,7 +13239,7 @@
               </a:spcAft>
             </a:pPr>
             <a:r>
-              <a:rPr sz="1250" b="1" i="0" lang="en-GB">
+              <a:rPr sz="1300" b="1" i="0" lang="en-GB">
                 <a:solidFill>
                   <a:srgbClr val="FFFFFF"/>
                 </a:solidFill>
@@ -13250,39 +13250,150 @@
               <a:t>Phase 0</a:t>
             </a:r>
           </a:p>
-          <a:p>
-            <a:pPr algn="ctr">
-              <a:spcBef>
-                <a:spcPts val="0"/>
-              </a:spcBef>
-              <a:spcAft>
-                <a:spcPts val="0"/>
-              </a:spcAft>
-            </a:pPr>
-            <a:r>
-              <a:rPr sz="1150" b="0" i="0" lang="en-GB">
-                <a:solidFill>
-                  <a:srgbClr val="FFFFFF"/>
-                </a:solidFill>
-                <a:latin typeface="Aptos"/>
-                <a:ea typeface="Aptos"/>
-                <a:cs typeface="Dubai"/>
-              </a:rPr>
-              <a:t>Week 1</a:t>
-            </a:r>
-          </a:p>
-        </p:txBody>
-      </p:sp>
-      <p:sp>
-        <p:nvSpPr>
-          <p:cNvPr id="10" name="Rounded Rectangle 9"/>
-          <p:cNvSpPr/>
-          <p:nvPr/>
-        </p:nvSpPr>
-        <p:spPr>
-          <a:xfrm>
-            <a:off x="1829816" y="1783080"/>
-            <a:ext cx="3624072" cy="566928"/>
+        </p:txBody>
+      </p:sp>
+      <p:sp>
+        <p:nvSpPr>
+          <p:cNvPr id="10" name="Chevron 9"/>
+          <p:cNvSpPr/>
+          <p:nvPr/>
+        </p:nvSpPr>
+        <p:spPr>
+          <a:xfrm>
+            <a:off x="3211830" y="1947672"/>
+            <a:ext cx="128016" cy="237744"/>
+          </a:xfrm>
+          <a:prstGeom prst="chevron">
+            <a:avLst/>
+          </a:prstGeom>
+          <a:solidFill>
+            <a:srgbClr val="D5DBE1"/>
+          </a:solidFill>
+          <a:ln>
+            <a:noFill/>
+          </a:ln>
+          <a:effectLst/>
+        </p:spPr>
+        <p:style>
+          <a:lnRef idx="1">
+            <a:schemeClr val="accent1"/>
+          </a:lnRef>
+          <a:fillRef idx="3">
+            <a:schemeClr val="accent1"/>
+          </a:fillRef>
+          <a:effectRef idx="2">
+            <a:schemeClr val="accent1"/>
+          </a:effectRef>
+          <a:fontRef idx="minor">
+            <a:schemeClr val="lt1"/>
+          </a:fontRef>
+        </p:style>
+        <p:txBody>
+          <a:bodyPr rtlCol="0" anchor="ctr"/>
+          <a:lstStyle/>
+          <a:p>
+            <a:pPr algn="ctr"/>
+          </a:p>
+        </p:txBody>
+      </p:sp>
+      <p:sp>
+        <p:nvSpPr>
+          <p:cNvPr id="11" name="TextBox 10"/>
+          <p:cNvSpPr txBox="1"/>
+          <p:nvPr/>
+        </p:nvSpPr>
+        <p:spPr>
+          <a:xfrm>
+            <a:off x="548640" y="2514600"/>
+            <a:ext cx="2635758" cy="365760"/>
+          </a:xfrm>
+          <a:prstGeom prst="rect">
+            <a:avLst/>
+          </a:prstGeom>
+          <a:noFill/>
+        </p:spPr>
+        <p:txBody>
+          <a:bodyPr wrap="square" lIns="0" tIns="0" rIns="0" bIns="0" anchor="t">
+            <a:noAutofit/>
+          </a:bodyPr>
+          <a:lstStyle/>
+          <a:p>
+            <a:pPr algn="l">
+              <a:spcBef>
+                <a:spcPts val="0"/>
+              </a:spcBef>
+              <a:spcAft>
+                <a:spcPts val="0"/>
+              </a:spcAft>
+            </a:pPr>
+            <a:r>
+              <a:rPr sz="1800" b="1" i="0" lang="en-GB">
+                <a:solidFill>
+                  <a:srgbClr val="0F2A44"/>
+                </a:solidFill>
+                <a:latin typeface="Aptos"/>
+                <a:ea typeface="Aptos"/>
+                <a:cs typeface="Dubai"/>
+              </a:rPr>
+              <a:t>Set-up</a:t>
+            </a:r>
+          </a:p>
+        </p:txBody>
+      </p:sp>
+      <p:sp>
+        <p:nvSpPr>
+          <p:cNvPr id="12" name="TextBox 11"/>
+          <p:cNvSpPr txBox="1"/>
+          <p:nvPr/>
+        </p:nvSpPr>
+        <p:spPr>
+          <a:xfrm>
+            <a:off x="548640" y="2880360"/>
+            <a:ext cx="2635758" cy="868680"/>
+          </a:xfrm>
+          <a:prstGeom prst="rect">
+            <a:avLst/>
+          </a:prstGeom>
+          <a:noFill/>
+        </p:spPr>
+        <p:txBody>
+          <a:bodyPr wrap="square" lIns="0" tIns="0" rIns="0" bIns="0" anchor="t">
+            <a:noAutofit/>
+          </a:bodyPr>
+          <a:lstStyle/>
+          <a:p>
+            <a:pPr algn="l">
+              <a:spcBef>
+                <a:spcPts val="0"/>
+              </a:spcBef>
+              <a:spcAft>
+                <a:spcPts val="0"/>
+              </a:spcAft>
+            </a:pPr>
+            <a:r>
+              <a:rPr sz="1350" b="0" i="0" lang="en-GB">
+                <a:solidFill>
+                  <a:srgbClr val="1F2937"/>
+                </a:solidFill>
+                <a:latin typeface="Aptos"/>
+                <a:ea typeface="Aptos"/>
+                <a:cs typeface="Dubai"/>
+              </a:rPr>
+              <a:t>Mac ready, about 10 public clips trimmed, right answers written down.</a:t>
+            </a:r>
+          </a:p>
+        </p:txBody>
+      </p:sp>
+      <p:sp>
+        <p:nvSpPr>
+          <p:cNvPr id="13" name="Rounded Rectangle 12"/>
+          <p:cNvSpPr/>
+          <p:nvPr/>
+        </p:nvSpPr>
+        <p:spPr>
+          <a:xfrm>
+            <a:off x="3367278" y="1783080"/>
+            <a:ext cx="2635758" cy="566928"/>
           </a:xfrm>
           <a:prstGeom prst="roundRect">
             <a:avLst>
@@ -13326,7 +13437,7 @@
               </a:spcAft>
             </a:pPr>
             <a:r>
-              <a:rPr sz="1250" b="1" i="0" lang="en-GB">
+              <a:rPr sz="1300" b="1" i="0" lang="en-GB">
                 <a:solidFill>
                   <a:srgbClr val="FFFFFF"/>
                 </a:solidFill>
@@ -13337,39 +13448,150 @@
               <a:t>Phase 1</a:t>
             </a:r>
           </a:p>
-          <a:p>
-            <a:pPr algn="ctr">
-              <a:spcBef>
-                <a:spcPts val="0"/>
-              </a:spcBef>
-              <a:spcAft>
-                <a:spcPts val="0"/>
-              </a:spcAft>
-            </a:pPr>
-            <a:r>
-              <a:rPr sz="1150" b="0" i="0" lang="en-GB">
-                <a:solidFill>
-                  <a:srgbClr val="FFFFFF"/>
-                </a:solidFill>
-                <a:latin typeface="Aptos"/>
-                <a:ea typeface="Aptos"/>
-                <a:cs typeface="Dubai"/>
-              </a:rPr>
-              <a:t>Weeks 2-4</a:t>
-            </a:r>
-          </a:p>
-        </p:txBody>
-      </p:sp>
-      <p:sp>
-        <p:nvSpPr>
-          <p:cNvPr id="11" name="Rounded Rectangle 10"/>
-          <p:cNvSpPr/>
-          <p:nvPr/>
-        </p:nvSpPr>
-        <p:spPr>
-          <a:xfrm>
-            <a:off x="5527040" y="1783080"/>
-            <a:ext cx="3624072" cy="566928"/>
+        </p:txBody>
+      </p:sp>
+      <p:sp>
+        <p:nvSpPr>
+          <p:cNvPr id="14" name="Chevron 13"/>
+          <p:cNvSpPr/>
+          <p:nvPr/>
+        </p:nvSpPr>
+        <p:spPr>
+          <a:xfrm>
+            <a:off x="6030468" y="1947672"/>
+            <a:ext cx="128016" cy="237744"/>
+          </a:xfrm>
+          <a:prstGeom prst="chevron">
+            <a:avLst/>
+          </a:prstGeom>
+          <a:solidFill>
+            <a:srgbClr val="D5DBE1"/>
+          </a:solidFill>
+          <a:ln>
+            <a:noFill/>
+          </a:ln>
+          <a:effectLst/>
+        </p:spPr>
+        <p:style>
+          <a:lnRef idx="1">
+            <a:schemeClr val="accent1"/>
+          </a:lnRef>
+          <a:fillRef idx="3">
+            <a:schemeClr val="accent1"/>
+          </a:fillRef>
+          <a:effectRef idx="2">
+            <a:schemeClr val="accent1"/>
+          </a:effectRef>
+          <a:fontRef idx="minor">
+            <a:schemeClr val="lt1"/>
+          </a:fontRef>
+        </p:style>
+        <p:txBody>
+          <a:bodyPr rtlCol="0" anchor="ctr"/>
+          <a:lstStyle/>
+          <a:p>
+            <a:pPr algn="ctr"/>
+          </a:p>
+        </p:txBody>
+      </p:sp>
+      <p:sp>
+        <p:nvSpPr>
+          <p:cNvPr id="15" name="TextBox 14"/>
+          <p:cNvSpPr txBox="1"/>
+          <p:nvPr/>
+        </p:nvSpPr>
+        <p:spPr>
+          <a:xfrm>
+            <a:off x="3367278" y="2514600"/>
+            <a:ext cx="2635758" cy="365760"/>
+          </a:xfrm>
+          <a:prstGeom prst="rect">
+            <a:avLst/>
+          </a:prstGeom>
+          <a:noFill/>
+        </p:spPr>
+        <p:txBody>
+          <a:bodyPr wrap="square" lIns="0" tIns="0" rIns="0" bIns="0" anchor="t">
+            <a:noAutofit/>
+          </a:bodyPr>
+          <a:lstStyle/>
+          <a:p>
+            <a:pPr algn="l">
+              <a:spcBef>
+                <a:spcPts val="0"/>
+              </a:spcBef>
+              <a:spcAft>
+                <a:spcPts val="0"/>
+              </a:spcAft>
+            </a:pPr>
+            <a:r>
+              <a:rPr sz="1800" b="1" i="0" lang="en-GB">
+                <a:solidFill>
+                  <a:srgbClr val="0F2A44"/>
+                </a:solidFill>
+                <a:latin typeface="Aptos"/>
+                <a:ea typeface="Aptos"/>
+                <a:cs typeface="Dubai"/>
+              </a:rPr>
+              <a:t>Baseline</a:t>
+            </a:r>
+          </a:p>
+        </p:txBody>
+      </p:sp>
+      <p:sp>
+        <p:nvSpPr>
+          <p:cNvPr id="16" name="TextBox 15"/>
+          <p:cNvSpPr txBox="1"/>
+          <p:nvPr/>
+        </p:nvSpPr>
+        <p:spPr>
+          <a:xfrm>
+            <a:off x="3367278" y="2880360"/>
+            <a:ext cx="2635758" cy="868680"/>
+          </a:xfrm>
+          <a:prstGeom prst="rect">
+            <a:avLst/>
+          </a:prstGeom>
+          <a:noFill/>
+        </p:spPr>
+        <p:txBody>
+          <a:bodyPr wrap="square" lIns="0" tIns="0" rIns="0" bIns="0" anchor="t">
+            <a:noAutofit/>
+          </a:bodyPr>
+          <a:lstStyle/>
+          <a:p>
+            <a:pPr algn="l">
+              <a:spcBef>
+                <a:spcPts val="0"/>
+              </a:spcBef>
+              <a:spcAft>
+                <a:spcPts val="0"/>
+              </a:spcAft>
+            </a:pPr>
+            <a:r>
+              <a:rPr sz="1350" b="0" i="0" lang="en-GB">
+                <a:solidFill>
+                  <a:srgbClr val="1F2937"/>
+                </a:solidFill>
+                <a:latin typeface="Aptos"/>
+                <a:ea typeface="Aptos"/>
+                <a:cs typeface="Dubai"/>
+              </a:rPr>
+              <a:t>Upload, detect, track, index. First Arabic search and test set.</a:t>
+            </a:r>
+          </a:p>
+        </p:txBody>
+      </p:sp>
+      <p:sp>
+        <p:nvSpPr>
+          <p:cNvPr id="17" name="Rounded Rectangle 16"/>
+          <p:cNvSpPr/>
+          <p:nvPr/>
+        </p:nvSpPr>
+        <p:spPr>
+          <a:xfrm>
+            <a:off x="6185916" y="1783080"/>
+            <a:ext cx="2635758" cy="566928"/>
           </a:xfrm>
           <a:prstGeom prst="roundRect">
             <a:avLst>
@@ -13413,7 +13635,7 @@
               </a:spcAft>
             </a:pPr>
             <a:r>
-              <a:rPr sz="1250" b="1" i="0" lang="en-GB">
+              <a:rPr sz="1300" b="1" i="0" lang="en-GB">
                 <a:solidFill>
                   <a:srgbClr val="FFFFFF"/>
                 </a:solidFill>
@@ -13424,39 +13646,150 @@
               <a:t>Phase 2</a:t>
             </a:r>
           </a:p>
-          <a:p>
-            <a:pPr algn="ctr">
-              <a:spcBef>
-                <a:spcPts val="0"/>
-              </a:spcBef>
-              <a:spcAft>
-                <a:spcPts val="0"/>
-              </a:spcAft>
-            </a:pPr>
-            <a:r>
-              <a:rPr sz="1150" b="0" i="0" lang="en-GB">
-                <a:solidFill>
-                  <a:srgbClr val="FFFFFF"/>
-                </a:solidFill>
-                <a:latin typeface="Aptos"/>
-                <a:ea typeface="Aptos"/>
-                <a:cs typeface="Dubai"/>
-              </a:rPr>
-              <a:t>Weeks 5-7</a:t>
-            </a:r>
-          </a:p>
-        </p:txBody>
-      </p:sp>
-      <p:sp>
-        <p:nvSpPr>
-          <p:cNvPr id="12" name="Rounded Rectangle 11"/>
-          <p:cNvSpPr/>
-          <p:nvPr/>
-        </p:nvSpPr>
-        <p:spPr>
-          <a:xfrm>
-            <a:off x="9224264" y="1783080"/>
-            <a:ext cx="2416048" cy="566928"/>
+        </p:txBody>
+      </p:sp>
+      <p:sp>
+        <p:nvSpPr>
+          <p:cNvPr id="18" name="Chevron 17"/>
+          <p:cNvSpPr/>
+          <p:nvPr/>
+        </p:nvSpPr>
+        <p:spPr>
+          <a:xfrm>
+            <a:off x="8849106" y="1947672"/>
+            <a:ext cx="128016" cy="237744"/>
+          </a:xfrm>
+          <a:prstGeom prst="chevron">
+            <a:avLst/>
+          </a:prstGeom>
+          <a:solidFill>
+            <a:srgbClr val="D5DBE1"/>
+          </a:solidFill>
+          <a:ln>
+            <a:noFill/>
+          </a:ln>
+          <a:effectLst/>
+        </p:spPr>
+        <p:style>
+          <a:lnRef idx="1">
+            <a:schemeClr val="accent1"/>
+          </a:lnRef>
+          <a:fillRef idx="3">
+            <a:schemeClr val="accent1"/>
+          </a:fillRef>
+          <a:effectRef idx="2">
+            <a:schemeClr val="accent1"/>
+          </a:effectRef>
+          <a:fontRef idx="minor">
+            <a:schemeClr val="lt1"/>
+          </a:fontRef>
+        </p:style>
+        <p:txBody>
+          <a:bodyPr rtlCol="0" anchor="ctr"/>
+          <a:lstStyle/>
+          <a:p>
+            <a:pPr algn="ctr"/>
+          </a:p>
+        </p:txBody>
+      </p:sp>
+      <p:sp>
+        <p:nvSpPr>
+          <p:cNvPr id="19" name="TextBox 18"/>
+          <p:cNvSpPr txBox="1"/>
+          <p:nvPr/>
+        </p:nvSpPr>
+        <p:spPr>
+          <a:xfrm>
+            <a:off x="6185916" y="2514600"/>
+            <a:ext cx="2635758" cy="365760"/>
+          </a:xfrm>
+          <a:prstGeom prst="rect">
+            <a:avLst/>
+          </a:prstGeom>
+          <a:noFill/>
+        </p:spPr>
+        <p:txBody>
+          <a:bodyPr wrap="square" lIns="0" tIns="0" rIns="0" bIns="0" anchor="t">
+            <a:noAutofit/>
+          </a:bodyPr>
+          <a:lstStyle/>
+          <a:p>
+            <a:pPr algn="l">
+              <a:spcBef>
+                <a:spcPts val="0"/>
+              </a:spcBef>
+              <a:spcAft>
+                <a:spcPts val="0"/>
+              </a:spcAft>
+            </a:pPr>
+            <a:r>
+              <a:rPr sz="1800" b="1" i="0" lang="en-GB">
+                <a:solidFill>
+                  <a:srgbClr val="0F2A44"/>
+                </a:solidFill>
+                <a:latin typeface="Aptos"/>
+                <a:ea typeface="Aptos"/>
+                <a:cs typeface="Dubai"/>
+              </a:rPr>
+              <a:t>Arabic hybrid</a:t>
+            </a:r>
+          </a:p>
+        </p:txBody>
+      </p:sp>
+      <p:sp>
+        <p:nvSpPr>
+          <p:cNvPr id="20" name="TextBox 19"/>
+          <p:cNvSpPr txBox="1"/>
+          <p:nvPr/>
+        </p:nvSpPr>
+        <p:spPr>
+          <a:xfrm>
+            <a:off x="6185916" y="2880360"/>
+            <a:ext cx="2635758" cy="868680"/>
+          </a:xfrm>
+          <a:prstGeom prst="rect">
+            <a:avLst/>
+          </a:prstGeom>
+          <a:noFill/>
+        </p:spPr>
+        <p:txBody>
+          <a:bodyPr wrap="square" lIns="0" tIns="0" rIns="0" bIns="0" anchor="t">
+            <a:noAutofit/>
+          </a:bodyPr>
+          <a:lstStyle/>
+          <a:p>
+            <a:pPr algn="l">
+              <a:spcBef>
+                <a:spcPts val="0"/>
+              </a:spcBef>
+              <a:spcAft>
+                <a:spcPts val="0"/>
+              </a:spcAft>
+            </a:pPr>
+            <a:r>
+              <a:rPr sz="1350" b="0" i="0" lang="en-GB">
+                <a:solidFill>
+                  <a:srgbClr val="1F2937"/>
+                </a:solidFill>
+                <a:latin typeface="Aptos"/>
+                <a:ea typeface="Aptos"/>
+                <a:cs typeface="Dubai"/>
+              </a:rPr>
+              <a:t>Dialect-aware query reading, clothing details, double-check step.</a:t>
+            </a:r>
+          </a:p>
+        </p:txBody>
+      </p:sp>
+      <p:sp>
+        <p:nvSpPr>
+          <p:cNvPr id="21" name="Rounded Rectangle 20"/>
+          <p:cNvSpPr/>
+          <p:nvPr/>
+        </p:nvSpPr>
+        <p:spPr>
+          <a:xfrm>
+            <a:off x="9004554" y="1783080"/>
+            <a:ext cx="2635758" cy="566928"/>
           </a:xfrm>
           <a:prstGeom prst="roundRect">
             <a:avLst>
@@ -13500,7 +13833,7 @@
               </a:spcAft>
             </a:pPr>
             <a:r>
-              <a:rPr sz="1250" b="1" i="0" lang="en-GB">
+              <a:rPr sz="1300" b="1" i="0" lang="en-GB">
                 <a:solidFill>
                   <a:srgbClr val="FFFFFF"/>
                 </a:solidFill>
@@ -13511,38 +13844,17 @@
               <a:t>Phase 3</a:t>
             </a:r>
           </a:p>
-          <a:p>
-            <a:pPr algn="ctr">
-              <a:spcBef>
-                <a:spcPts val="0"/>
-              </a:spcBef>
-              <a:spcAft>
-                <a:spcPts val="0"/>
-              </a:spcAft>
-            </a:pPr>
-            <a:r>
-              <a:rPr sz="1150" b="0" i="0" lang="en-GB">
-                <a:solidFill>
-                  <a:srgbClr val="FFFFFF"/>
-                </a:solidFill>
-                <a:latin typeface="Aptos"/>
-                <a:ea typeface="Aptos"/>
-                <a:cs typeface="Dubai"/>
-              </a:rPr>
-              <a:t>Weeks 8-9</a:t>
-            </a:r>
-          </a:p>
-        </p:txBody>
-      </p:sp>
-      <p:sp>
-        <p:nvSpPr>
-          <p:cNvPr id="13" name="TextBox 12"/>
+        </p:txBody>
+      </p:sp>
+      <p:sp>
+        <p:nvSpPr>
+          <p:cNvPr id="22" name="TextBox 21"/>
           <p:cNvSpPr txBox="1"/>
           <p:nvPr/>
         </p:nvSpPr>
         <p:spPr>
           <a:xfrm>
-            <a:off x="548640" y="2514600"/>
+            <a:off x="9004554" y="2514600"/>
             <a:ext cx="2635758" cy="365760"/>
           </a:xfrm>
           <a:prstGeom prst="rect">
@@ -13573,20 +13885,20 @@
                 <a:ea typeface="Aptos"/>
                 <a:cs typeface="Dubai"/>
               </a:rPr>
-              <a:t>Set-up</a:t>
-            </a:r>
-          </a:p>
-        </p:txBody>
-      </p:sp>
-      <p:sp>
-        <p:nvSpPr>
-          <p:cNvPr id="14" name="TextBox 13"/>
+              <a:t>Demo-ready</a:t>
+            </a:r>
+          </a:p>
+        </p:txBody>
+      </p:sp>
+      <p:sp>
+        <p:nvSpPr>
+          <p:cNvPr id="23" name="TextBox 22"/>
           <p:cNvSpPr txBox="1"/>
           <p:nvPr/>
         </p:nvSpPr>
         <p:spPr>
           <a:xfrm>
-            <a:off x="548640" y="2880360"/>
+            <a:off x="9004554" y="2880360"/>
             <a:ext cx="2635758" cy="868680"/>
           </a:xfrm>
           <a:prstGeom prst="rect">
@@ -13617,21 +13929,21 @@
                 <a:ea typeface="Aptos"/>
                 <a:cs typeface="Dubai"/>
               </a:rPr>
-              <a:t>Mac ready, about 10 public clips trimmed, right answers written down.</a:t>
-            </a:r>
-          </a:p>
-        </p:txBody>
-      </p:sp>
-      <p:sp>
-        <p:nvSpPr>
-          <p:cNvPr id="15" name="TextBox 14"/>
+              <a:t>Timeline across cameras, audit log, demo script, results write-up.</a:t>
+            </a:r>
+          </a:p>
+        </p:txBody>
+      </p:sp>
+      <p:sp>
+        <p:nvSpPr>
+          <p:cNvPr id="24" name="TextBox 23"/>
           <p:cNvSpPr txBox="1"/>
           <p:nvPr/>
         </p:nvSpPr>
         <p:spPr>
           <a:xfrm>
-            <a:off x="3367278" y="2514600"/>
-            <a:ext cx="2635758" cy="365760"/>
+            <a:off x="548640" y="3931920"/>
+            <a:ext cx="5486400" cy="292608"/>
           </a:xfrm>
           <a:prstGeom prst="rect">
             <a:avLst/>
@@ -13653,270 +13965,6 @@
               </a:spcAft>
             </a:pPr>
             <a:r>
-              <a:rPr sz="1800" b="1" i="0" lang="en-GB">
-                <a:solidFill>
-                  <a:srgbClr val="0F2A44"/>
-                </a:solidFill>
-                <a:latin typeface="Aptos"/>
-                <a:ea typeface="Aptos"/>
-                <a:cs typeface="Dubai"/>
-              </a:rPr>
-              <a:t>Baseline</a:t>
-            </a:r>
-          </a:p>
-        </p:txBody>
-      </p:sp>
-      <p:sp>
-        <p:nvSpPr>
-          <p:cNvPr id="16" name="TextBox 15"/>
-          <p:cNvSpPr txBox="1"/>
-          <p:nvPr/>
-        </p:nvSpPr>
-        <p:spPr>
-          <a:xfrm>
-            <a:off x="3367278" y="2880360"/>
-            <a:ext cx="2635758" cy="868680"/>
-          </a:xfrm>
-          <a:prstGeom prst="rect">
-            <a:avLst/>
-          </a:prstGeom>
-          <a:noFill/>
-        </p:spPr>
-        <p:txBody>
-          <a:bodyPr wrap="square" lIns="0" tIns="0" rIns="0" bIns="0" anchor="t">
-            <a:noAutofit/>
-          </a:bodyPr>
-          <a:lstStyle/>
-          <a:p>
-            <a:pPr algn="l">
-              <a:spcBef>
-                <a:spcPts val="0"/>
-              </a:spcBef>
-              <a:spcAft>
-                <a:spcPts val="0"/>
-              </a:spcAft>
-            </a:pPr>
-            <a:r>
-              <a:rPr sz="1350" b="0" i="0" lang="en-GB">
-                <a:solidFill>
-                  <a:srgbClr val="1F2937"/>
-                </a:solidFill>
-                <a:latin typeface="Aptos"/>
-                <a:ea typeface="Aptos"/>
-                <a:cs typeface="Dubai"/>
-              </a:rPr>
-              <a:t>Upload, detect, track, index. First Arabic search and test set.</a:t>
-            </a:r>
-          </a:p>
-        </p:txBody>
-      </p:sp>
-      <p:sp>
-        <p:nvSpPr>
-          <p:cNvPr id="17" name="TextBox 16"/>
-          <p:cNvSpPr txBox="1"/>
-          <p:nvPr/>
-        </p:nvSpPr>
-        <p:spPr>
-          <a:xfrm>
-            <a:off x="6185916" y="2514600"/>
-            <a:ext cx="2635758" cy="365760"/>
-          </a:xfrm>
-          <a:prstGeom prst="rect">
-            <a:avLst/>
-          </a:prstGeom>
-          <a:noFill/>
-        </p:spPr>
-        <p:txBody>
-          <a:bodyPr wrap="square" lIns="0" tIns="0" rIns="0" bIns="0" anchor="t">
-            <a:noAutofit/>
-          </a:bodyPr>
-          <a:lstStyle/>
-          <a:p>
-            <a:pPr algn="l">
-              <a:spcBef>
-                <a:spcPts val="0"/>
-              </a:spcBef>
-              <a:spcAft>
-                <a:spcPts val="0"/>
-              </a:spcAft>
-            </a:pPr>
-            <a:r>
-              <a:rPr sz="1800" b="1" i="0" lang="en-GB">
-                <a:solidFill>
-                  <a:srgbClr val="0F2A44"/>
-                </a:solidFill>
-                <a:latin typeface="Aptos"/>
-                <a:ea typeface="Aptos"/>
-                <a:cs typeface="Dubai"/>
-              </a:rPr>
-              <a:t>Arabic hybrid</a:t>
-            </a:r>
-          </a:p>
-        </p:txBody>
-      </p:sp>
-      <p:sp>
-        <p:nvSpPr>
-          <p:cNvPr id="18" name="TextBox 17"/>
-          <p:cNvSpPr txBox="1"/>
-          <p:nvPr/>
-        </p:nvSpPr>
-        <p:spPr>
-          <a:xfrm>
-            <a:off x="6185916" y="2880360"/>
-            <a:ext cx="2635758" cy="868680"/>
-          </a:xfrm>
-          <a:prstGeom prst="rect">
-            <a:avLst/>
-          </a:prstGeom>
-          <a:noFill/>
-        </p:spPr>
-        <p:txBody>
-          <a:bodyPr wrap="square" lIns="0" tIns="0" rIns="0" bIns="0" anchor="t">
-            <a:noAutofit/>
-          </a:bodyPr>
-          <a:lstStyle/>
-          <a:p>
-            <a:pPr algn="l">
-              <a:spcBef>
-                <a:spcPts val="0"/>
-              </a:spcBef>
-              <a:spcAft>
-                <a:spcPts val="0"/>
-              </a:spcAft>
-            </a:pPr>
-            <a:r>
-              <a:rPr sz="1350" b="0" i="0" lang="en-GB">
-                <a:solidFill>
-                  <a:srgbClr val="1F2937"/>
-                </a:solidFill>
-                <a:latin typeface="Aptos"/>
-                <a:ea typeface="Aptos"/>
-                <a:cs typeface="Dubai"/>
-              </a:rPr>
-              <a:t>Dialect-aware query reading, clothing details, double-check step.</a:t>
-            </a:r>
-          </a:p>
-        </p:txBody>
-      </p:sp>
-      <p:sp>
-        <p:nvSpPr>
-          <p:cNvPr id="19" name="TextBox 18"/>
-          <p:cNvSpPr txBox="1"/>
-          <p:nvPr/>
-        </p:nvSpPr>
-        <p:spPr>
-          <a:xfrm>
-            <a:off x="9004554" y="2514600"/>
-            <a:ext cx="2635758" cy="365760"/>
-          </a:xfrm>
-          <a:prstGeom prst="rect">
-            <a:avLst/>
-          </a:prstGeom>
-          <a:noFill/>
-        </p:spPr>
-        <p:txBody>
-          <a:bodyPr wrap="square" lIns="0" tIns="0" rIns="0" bIns="0" anchor="t">
-            <a:noAutofit/>
-          </a:bodyPr>
-          <a:lstStyle/>
-          <a:p>
-            <a:pPr algn="l">
-              <a:spcBef>
-                <a:spcPts val="0"/>
-              </a:spcBef>
-              <a:spcAft>
-                <a:spcPts val="0"/>
-              </a:spcAft>
-            </a:pPr>
-            <a:r>
-              <a:rPr sz="1800" b="1" i="0" lang="en-GB">
-                <a:solidFill>
-                  <a:srgbClr val="0F2A44"/>
-                </a:solidFill>
-                <a:latin typeface="Aptos"/>
-                <a:ea typeface="Aptos"/>
-                <a:cs typeface="Dubai"/>
-              </a:rPr>
-              <a:t>Demo-ready</a:t>
-            </a:r>
-          </a:p>
-        </p:txBody>
-      </p:sp>
-      <p:sp>
-        <p:nvSpPr>
-          <p:cNvPr id="20" name="TextBox 19"/>
-          <p:cNvSpPr txBox="1"/>
-          <p:nvPr/>
-        </p:nvSpPr>
-        <p:spPr>
-          <a:xfrm>
-            <a:off x="9004554" y="2880360"/>
-            <a:ext cx="2635758" cy="868680"/>
-          </a:xfrm>
-          <a:prstGeom prst="rect">
-            <a:avLst/>
-          </a:prstGeom>
-          <a:noFill/>
-        </p:spPr>
-        <p:txBody>
-          <a:bodyPr wrap="square" lIns="0" tIns="0" rIns="0" bIns="0" anchor="t">
-            <a:noAutofit/>
-          </a:bodyPr>
-          <a:lstStyle/>
-          <a:p>
-            <a:pPr algn="l">
-              <a:spcBef>
-                <a:spcPts val="0"/>
-              </a:spcBef>
-              <a:spcAft>
-                <a:spcPts val="0"/>
-              </a:spcAft>
-            </a:pPr>
-            <a:r>
-              <a:rPr sz="1350" b="0" i="0" lang="en-GB">
-                <a:solidFill>
-                  <a:srgbClr val="1F2937"/>
-                </a:solidFill>
-                <a:latin typeface="Aptos"/>
-                <a:ea typeface="Aptos"/>
-                <a:cs typeface="Dubai"/>
-              </a:rPr>
-              <a:t>Timeline across cameras, audit log, demo script, results write-up.</a:t>
-            </a:r>
-          </a:p>
-        </p:txBody>
-      </p:sp>
-      <p:sp>
-        <p:nvSpPr>
-          <p:cNvPr id="21" name="TextBox 20"/>
-          <p:cNvSpPr txBox="1"/>
-          <p:nvPr/>
-        </p:nvSpPr>
-        <p:spPr>
-          <a:xfrm>
-            <a:off x="548640" y="3931920"/>
-            <a:ext cx="5486400" cy="292608"/>
-          </a:xfrm>
-          <a:prstGeom prst="rect">
-            <a:avLst/>
-          </a:prstGeom>
-          <a:noFill/>
-        </p:spPr>
-        <p:txBody>
-          <a:bodyPr wrap="square" lIns="0" tIns="0" rIns="0" bIns="0" anchor="t">
-            <a:noAutofit/>
-          </a:bodyPr>
-          <a:lstStyle/>
-          <a:p>
-            <a:pPr algn="l">
-              <a:spcBef>
-                <a:spcPts val="0"/>
-              </a:spcBef>
-              <a:spcAft>
-                <a:spcPts val="0"/>
-              </a:spcAft>
-            </a:pPr>
-            <a:r>
               <a:rPr sz="1100" b="1" i="0" lang="en-GB">
                 <a:solidFill>
                   <a:srgbClr val="5B6573"/>
@@ -13932,7 +13980,7 @@
       </p:sp>
       <p:sp>
         <p:nvSpPr>
-          <p:cNvPr id="22" name="Rounded Rectangle 21"/>
+          <p:cNvPr id="25" name="Rounded Rectangle 24"/>
           <p:cNvSpPr/>
           <p:nvPr/>
         </p:nvSpPr>
@@ -14019,7 +14067,7 @@
       </p:sp>
       <p:sp>
         <p:nvSpPr>
-          <p:cNvPr id="23" name="Chevron 22"/>
+          <p:cNvPr id="26" name="Chevron 25"/>
           <p:cNvSpPr/>
           <p:nvPr/>
         </p:nvSpPr>
@@ -14063,7 +14111,7 @@
       </p:sp>
       <p:sp>
         <p:nvSpPr>
-          <p:cNvPr id="24" name="Rounded Rectangle 23"/>
+          <p:cNvPr id="27" name="Rounded Rectangle 26"/>
           <p:cNvSpPr/>
           <p:nvPr/>
         </p:nvSpPr>
@@ -14150,7 +14198,7 @@
       </p:sp>
       <p:sp>
         <p:nvSpPr>
-          <p:cNvPr id="25" name="Chevron 24"/>
+          <p:cNvPr id="28" name="Chevron 27"/>
           <p:cNvSpPr/>
           <p:nvPr/>
         </p:nvSpPr>
@@ -14194,7 +14242,7 @@
       </p:sp>
       <p:sp>
         <p:nvSpPr>
-          <p:cNvPr id="26" name="Rounded Rectangle 25"/>
+          <p:cNvPr id="29" name="Rounded Rectangle 28"/>
           <p:cNvSpPr/>
           <p:nvPr/>
         </p:nvSpPr>
@@ -14281,7 +14329,7 @@
       </p:sp>
       <p:sp>
         <p:nvSpPr>
-          <p:cNvPr id="27" name="Rounded Rectangle 26"/>
+          <p:cNvPr id="30" name="Rounded Rectangle 29"/>
           <p:cNvSpPr/>
           <p:nvPr/>
         </p:nvSpPr>
@@ -14431,7 +14479,7 @@
       </p:sp>
       <p:sp>
         <p:nvSpPr>
-          <p:cNvPr id="28" name="Rounded Rectangle 27"/>
+          <p:cNvPr id="31" name="Rounded Rectangle 30"/>
           <p:cNvSpPr/>
           <p:nvPr/>
         </p:nvSpPr>

</xml_diff>

<commit_message>
docs: rework the deck's targets slide against phase 2 results
Slide 12 now pairs each proposed target with what phase 2 measured in
the README (met, missed or not measured), the roadmap slide is removed,
and the deck no longer names the hardware it runs on.
</commit_message>
<xml_diff>
--- a/docs/deck/arabic-video-search-use-cases.pptx
+++ b/docs/deck/arabic-video-search-use-cases.pptx
@@ -17,7 +17,6 @@
     <p:sldId id="265" r:id="rId17"/>
     <p:sldId id="266" r:id="rId18"/>
     <p:sldId id="267" r:id="rId19"/>
-    <p:sldId id="268" r:id="rId20"/>
   </p:sldIdLst>
   <p:sldSz cx="12191695" cy="6858000" type="screen4x3"/>
   <p:notesSz cx="6858000" cy="9144000"/>
@@ -716,7 +715,7 @@
           </a:p>
           <a:p>
             <a:r>
-              <a:t>Where it runs (D3): the captain's Mac (M4, 48 GB). App services in Docker; models native on macOS, because Docker containers on a Mac cannot use the Apple GPU (https://www.docker.com/blog/docker-model-runner-vllm-metal-macos/).</a:t>
+              <a:t>Where it runs (D3): one local computer. App services in Docker; the models run directly on the computer, because Docker containers there cannot use its GPU.</a:t>
             </a:r>
           </a:p>
           <a:p>
@@ -802,123 +801,42 @@
           <a:lstStyle/>
           <a:p>
             <a:r>
-              <a:t>Success measures as proposed in the plan (report section 6). These are targets set by the plan, not results.</a:t>
-            </a:r>
-          </a:p>
-          <a:p>
-            <a:r>
-              <a:t>The test set is about 100 queries on the demo clips (the plan's D4 answer suggests 80-120), written by us across formal Arabic, Jordanian, Gulf and mixed Arabic-English, because no public benchmark covers dialect queries against images (report section 2).</a:t>
-            </a:r>
-          </a:p>
-          <a:p>
-            <a:r>
-              <a:t>Main technical risk: dialect robustness of image-text models is untested anywhere (report, "Gaps and unverified items").</a:t>
-            </a:r>
-          </a:p>
-          <a:p/>
-          <a:p>
-            <a:r>
-              <a:t>Source: Arabic AI Video Search PoC technical plan, report file:///Users/ahmad.hammad/Desktop/Repos/firstmate/data/avs-technical-plan/report.md and board file:///Users/ahmad.hammad/Desktop/Repos/firstmate/data/avs-technical-plan/board.html</a:t>
-            </a:r>
-          </a:p>
-        </p:txBody>
-      </p:sp>
-      <p:sp>
-        <p:nvSpPr>
-          <p:cNvPr id="4" name="Slide Number Placeholder 3"/>
-          <p:cNvSpPr>
-            <a:spLocks noGrp="1"/>
-          </p:cNvSpPr>
-          <p:nvPr>
-            <p:ph type="sldNum" idx="5" sz="quarter"/>
-          </p:nvPr>
-        </p:nvSpPr>
-        <p:spPr/>
-      </p:sp>
-    </p:spTree>
-  </p:cSld>
-  <p:clrMapOvr>
-    <a:masterClrMapping/>
-  </p:clrMapOvr>
-</p:notes>
-</file>
-
-<file path=ppt/notesSlides/notesSlide13.xml><?xml version="1.0" encoding="utf-8"?>
-<p:notes xmlns:a="http://schemas.openxmlformats.org/drawingml/2006/main" xmlns:p="http://schemas.openxmlformats.org/presentationml/2006/main" xmlns:r="http://schemas.openxmlformats.org/officeDocument/2006/relationships">
-  <p:cSld>
-    <p:spTree>
-      <p:nvGrpSpPr>
-        <p:cNvPr id="1" name=""/>
-        <p:cNvGrpSpPr/>
-        <p:nvPr/>
-      </p:nvGrpSpPr>
-      <p:grpSpPr>
-        <a:xfrm>
-          <a:off x="0" y="0"/>
-          <a:ext cx="0" cy="0"/>
-          <a:chOff x="0" y="0"/>
-          <a:chExt cx="0" cy="0"/>
-        </a:xfrm>
-      </p:grpSpPr>
-      <p:sp>
-        <p:nvSpPr>
-          <p:cNvPr id="2" name="Slide Image Placeholder 1"/>
-          <p:cNvSpPr>
-            <a:spLocks noGrp="1"/>
-          </p:cNvSpPr>
-          <p:nvPr>
-            <p:ph type="sldImg" idx="2"/>
-          </p:nvPr>
-        </p:nvSpPr>
-        <p:spPr/>
-      </p:sp>
-      <p:sp>
-        <p:nvSpPr>
-          <p:cNvPr id="3" name="Notes Placeholder 2"/>
-          <p:cNvSpPr>
-            <a:spLocks noGrp="1"/>
-          </p:cNvSpPr>
-          <p:nvPr>
-            <p:ph type="body" idx="3" sz="quarter"/>
-          </p:nvPr>
-        </p:nvSpPr>
-        <p:spPr/>
-        <p:txBody>
-          <a:bodyPr/>
-          <a:lstStyle/>
-          <a:p>
-            <a:r>
-              <a:t>Phases, in order (report section 6); no time estimates are given here:</a:t>
-            </a:r>
-          </a:p>
-          <a:p>
-            <a:r>
-              <a:t>Phase 0 set-up: Mac set up, clips downloaded and trimmed, ground truth written.</a:t>
-            </a:r>
-          </a:p>
-          <a:p>
-            <a:r>
-              <a:t>Phase 1 baseline with option A (direct multilingual embedding).</a:t>
-            </a:r>
-          </a:p>
-          <a:p>
-            <a:r>
-              <a:t>Phase 2 Arabic hybrid (query parser, attributes, double-check).</a:t>
-            </a:r>
-          </a:p>
-          <a:p>
-            <a:r>
-              <a:t>Phase 3 demo-ready.</a:t>
-            </a:r>
-          </a:p>
-          <a:p>
-            <a:r>
-              <a:t>Team: 1 CV/ML engineer, 1 full-stack engineer, a part-time native Arabic speaker, and a part-time PM/legal for dataset licences, attribution and the impact assessment.</a:t>
-            </a:r>
-          </a:p>
-          <a:p>
-            <a:r>
-              <a:t>After the PoC (report section 4): a single-site pilot is realistic with a partner; a district needs a public-sector sponsor; city-wide is a government programme. Production hardware is sized separately (decision D3).</a:t>
+              <a:t>Targets as proposed in the plan (report section 6), still to be agreed. Each is paired with what phase 2 measured, from the project README, section "Evaluation: phase 1 and phase 2 side by side", and its timings of the clean run.</a:t>
+            </a:r>
+          </a:p>
+          <a:p>
+            <a:r>
+              <a:t>Test set: 113 queries written by us on the demo clips, 110 of them with a target (three match nobody), across formal Arabic, Jordanian, Gulf, mixed Arabic-English and English. No public benchmark covers dialect queries against images (report section 2).</a:t>
+            </a:r>
+          </a:p>
+          <a:p>
+            <a:r>
+              <a:t>Top 10: the hybrid finds a correct track for 109 of 110 (99%), option A for 100 (91%). The fusion settings were tuned on the first 47 scored queries; on the 63 written afterwards the hybrid scores 98% and option A 95%, the fairer estimate.</a:t>
+            </a:r>
+          </a:p>
+          <a:p>
+            <a:r>
+              <a:t>Dialect gap, measured on top-10 hit rate: hybrid Jordanian 100%, Gulf 100%, formal 100%; option A Jordanian 80% against formal 97%.</a:t>
+            </a:r>
+          </a:p>
+          <a:p>
+            <a:r>
+              <a:t>3 of 5: precision at 5 is 0.51 for the hybrid's first ranking, 0.49 after the double-check, 0.44 for option A. It is capped for targets seen in fewer than 5 tracks.</a:t>
+            </a:r>
+          </a:p>
+          <a:p>
+            <a:r>
+              <a:t>Indexing: the 11 starter clips (486 tracks) took 44 minutes, 36.5 of them for the vision model's attributes, against about 7 minutes without them.</a:t>
+            </a:r>
+          </a:p>
+          <a:p>
+            <a:r>
+              <a:t>Speed: hybrid first results median 2.1 s, 90th percentile 2.3 s, under 5 s for 112 of 113 searches; the double-check of the top 8 adds a median 17.2 s and fills in after.</a:t>
+            </a:r>
+          </a:p>
+          <a:p>
+            <a:r>
+              <a:t>Officer time per story: not measured in phase 2.</a:t>
             </a:r>
           </a:p>
           <a:p/>
@@ -6512,7 +6430,7 @@
                 <a:ea typeface="Aptos"/>
                 <a:cs typeface="Dubai"/>
               </a:rPr>
-              <a:t>10 / 13</a:t>
+              <a:t>10 / 12</a:t>
             </a:r>
           </a:p>
         </p:txBody>
@@ -8328,7 +8246,7 @@
                 <a:ea typeface="Aptos"/>
                 <a:cs typeface="Dubai"/>
               </a:rPr>
-              <a:t>11 / 13</a:t>
+              <a:t>11 / 12</a:t>
             </a:r>
           </a:p>
         </p:txBody>
@@ -11353,7 +11271,7 @@
                 <a:ea typeface="Aptos"/>
                 <a:cs typeface="Dubai"/>
               </a:rPr>
-              <a:t>Runs on one Mac (M4, 48 GB): </a:t>
+              <a:t>Runs on one computer: </a:t>
             </a:r>
             <a:r>
               <a:rPr sz="1350" b="0" i="0" lang="en-GB">
@@ -11364,7 +11282,7 @@
                 <a:ea typeface="Aptos"/>
                 <a:cs typeface="Dubai"/>
               </a:rPr>
-              <a:t>the app in Docker, the AI models on the Mac itself. Recorded clips from public datasets, no live cameras, and no cloud AI.</a:t>
+              <a:t>the app in Docker, the AI models on the computer itself. Recorded clips from public datasets, no live cameras, and no cloud AI.</a:t>
             </a:r>
           </a:p>
         </p:txBody>
@@ -11587,7 +11505,7 @@
                 <a:ea typeface="Aptos"/>
                 <a:cs typeface="Dubai"/>
               </a:rPr>
-              <a:t>12 / 13</a:t>
+              <a:t>12 / 12</a:t>
             </a:r>
           </a:p>
         </p:txBody>
@@ -11722,7 +11640,7 @@
                 <a:ea typeface="Aptos"/>
                 <a:cs typeface="Dubai"/>
               </a:rPr>
-              <a:t>Proposed targets for the demo, to be agreed</a:t>
+              <a:t>The proposed targets against phase 2: three met, two missed, one not yet measured</a:t>
             </a:r>
           </a:p>
         </p:txBody>
@@ -11735,8 +11653,8 @@
         </p:nvSpPr>
         <p:spPr>
           <a:xfrm>
-            <a:off x="548640" y="1783080"/>
-            <a:ext cx="3566160" cy="1572768"/>
+            <a:off x="548640" y="1737360"/>
+            <a:ext cx="3566160" cy="1719072"/>
           </a:xfrm>
           <a:prstGeom prst="roundRect">
             <a:avLst>
@@ -11781,8 +11699,8 @@
         </p:nvSpPr>
         <p:spPr>
           <a:xfrm>
-            <a:off x="548640" y="2011680"/>
-            <a:ext cx="64008" cy="1115568"/>
+            <a:off x="548640" y="1920240"/>
+            <a:ext cx="64008" cy="1353312"/>
           </a:xfrm>
           <a:prstGeom prst="rect">
             <a:avLst/>
@@ -11825,8 +11743,8 @@
         </p:nvSpPr>
         <p:spPr>
           <a:xfrm>
-            <a:off x="822959" y="1984248"/>
-            <a:ext cx="3108960" cy="640080"/>
+            <a:off x="822959" y="1865376"/>
+            <a:ext cx="2011680" cy="457200"/>
           </a:xfrm>
           <a:prstGeom prst="rect">
             <a:avLst/>
@@ -11848,7 +11766,7 @@
               </a:spcAft>
             </a:pPr>
             <a:r>
-              <a:rPr sz="3400" b="1" i="0" lang="en-GB">
+              <a:rPr sz="2600" b="1" i="0" lang="en-GB">
                 <a:solidFill>
                   <a:srgbClr val="0F2A44"/>
                 </a:solidFill>
@@ -11863,27 +11781,51 @@
       </p:sp>
       <p:sp>
         <p:nvSpPr>
-          <p:cNvPr id="12" name="TextBox 11"/>
-          <p:cNvSpPr txBox="1"/>
-          <p:nvPr/>
-        </p:nvSpPr>
-        <p:spPr>
-          <a:xfrm>
-            <a:off x="822959" y="2651760"/>
-            <a:ext cx="3108960" cy="640080"/>
-          </a:xfrm>
-          <a:prstGeom prst="rect">
-            <a:avLst/>
-          </a:prstGeom>
-          <a:noFill/>
-        </p:spPr>
-        <p:txBody>
-          <a:bodyPr wrap="square" lIns="0" tIns="0" rIns="0" bIns="0" anchor="t">
+          <p:cNvPr id="12" name="Rounded Rectangle 11"/>
+          <p:cNvSpPr/>
+          <p:nvPr/>
+        </p:nvSpPr>
+        <p:spPr>
+          <a:xfrm>
+            <a:off x="3063239" y="1920240"/>
+            <a:ext cx="868680" cy="274320"/>
+          </a:xfrm>
+          <a:prstGeom prst="roundRect">
+            <a:avLst>
+              <a:gd name="adj" fmla="val 50000"/>
+            </a:avLst>
+          </a:prstGeom>
+          <a:solidFill>
+            <a:srgbClr val="E3F2F1"/>
+          </a:solidFill>
+          <a:ln w="12700">
+            <a:solidFill>
+              <a:srgbClr val="0E7C7B"/>
+            </a:solidFill>
+          </a:ln>
+          <a:effectLst/>
+        </p:spPr>
+        <p:style>
+          <a:lnRef idx="1">
+            <a:schemeClr val="accent1"/>
+          </a:lnRef>
+          <a:fillRef idx="3">
+            <a:schemeClr val="accent1"/>
+          </a:fillRef>
+          <a:effectRef idx="2">
+            <a:schemeClr val="accent1"/>
+          </a:effectRef>
+          <a:fontRef idx="minor">
+            <a:schemeClr val="lt1"/>
+          </a:fontRef>
+        </p:style>
+        <p:txBody>
+          <a:bodyPr rtlCol="0" anchor="ctr" wrap="square" lIns="27432" tIns="21945" rIns="27432" bIns="21945">
             <a:noAutofit/>
           </a:bodyPr>
           <a:lstStyle/>
           <a:p>
-            <a:pPr algn="l">
+            <a:pPr algn="ctr">
               <a:spcBef>
                 <a:spcPts val="0"/>
               </a:spcBef>
@@ -11892,1263 +11834,29 @@
               </a:spcAft>
             </a:pPr>
             <a:r>
-              <a:rPr sz="1400" b="0" i="0" lang="en-GB">
-                <a:solidFill>
-                  <a:srgbClr val="1F2937"/>
-                </a:solidFill>
-                <a:latin typeface="Aptos"/>
-                <a:ea typeface="Aptos"/>
-                <a:cs typeface="Dubai"/>
-              </a:rPr>
-              <a:t>of about 100 test queries find the right person in the top 10</a:t>
-            </a:r>
-          </a:p>
-        </p:txBody>
-      </p:sp>
-      <p:sp>
-        <p:nvSpPr>
-          <p:cNvPr id="13" name="Rounded Rectangle 12"/>
-          <p:cNvSpPr/>
-          <p:nvPr/>
-        </p:nvSpPr>
-        <p:spPr>
-          <a:xfrm>
-            <a:off x="4311396" y="1783080"/>
-            <a:ext cx="3566160" cy="1572768"/>
-          </a:xfrm>
-          <a:prstGeom prst="roundRect">
-            <a:avLst>
-              <a:gd name="adj" fmla="val 6000"/>
-            </a:avLst>
-          </a:prstGeom>
-          <a:solidFill>
-            <a:srgbClr val="F3F5F7"/>
-          </a:solidFill>
-          <a:ln>
-            <a:noFill/>
-          </a:ln>
-          <a:effectLst/>
-        </p:spPr>
-        <p:style>
-          <a:lnRef idx="1">
-            <a:schemeClr val="accent1"/>
-          </a:lnRef>
-          <a:fillRef idx="3">
-            <a:schemeClr val="accent1"/>
-          </a:fillRef>
-          <a:effectRef idx="2">
-            <a:schemeClr val="accent1"/>
-          </a:effectRef>
-          <a:fontRef idx="minor">
-            <a:schemeClr val="lt1"/>
-          </a:fontRef>
-        </p:style>
-        <p:txBody>
-          <a:bodyPr rtlCol="0" anchor="ctr"/>
-          <a:lstStyle/>
-          <a:p>
-            <a:pPr algn="ctr"/>
-          </a:p>
-        </p:txBody>
-      </p:sp>
-      <p:sp>
-        <p:nvSpPr>
-          <p:cNvPr id="14" name="Rectangle 13"/>
-          <p:cNvSpPr/>
-          <p:nvPr/>
-        </p:nvSpPr>
-        <p:spPr>
-          <a:xfrm>
-            <a:off x="4311396" y="2011680"/>
-            <a:ext cx="64008" cy="1115568"/>
-          </a:xfrm>
-          <a:prstGeom prst="rect">
-            <a:avLst/>
-          </a:prstGeom>
-          <a:solidFill>
-            <a:srgbClr val="0E7C7B"/>
-          </a:solidFill>
-          <a:ln>
-            <a:noFill/>
-          </a:ln>
-          <a:effectLst/>
-        </p:spPr>
-        <p:style>
-          <a:lnRef idx="1">
-            <a:schemeClr val="accent1"/>
-          </a:lnRef>
-          <a:fillRef idx="3">
-            <a:schemeClr val="accent1"/>
-          </a:fillRef>
-          <a:effectRef idx="2">
-            <a:schemeClr val="accent1"/>
-          </a:effectRef>
-          <a:fontRef idx="minor">
-            <a:schemeClr val="lt1"/>
-          </a:fontRef>
-        </p:style>
-        <p:txBody>
-          <a:bodyPr rtlCol="0" anchor="ctr"/>
-          <a:lstStyle/>
-          <a:p>
-            <a:pPr algn="ctr"/>
-          </a:p>
-        </p:txBody>
-      </p:sp>
-      <p:sp>
-        <p:nvSpPr>
-          <p:cNvPr id="15" name="TextBox 14"/>
+              <a:rPr sz="950" b="1" i="0" lang="en-GB">
+                <a:solidFill>
+                  <a:srgbClr val="0E7C7B"/>
+                </a:solidFill>
+                <a:latin typeface="Aptos"/>
+                <a:ea typeface="Aptos"/>
+                <a:cs typeface="Dubai"/>
+              </a:rPr>
+              <a:t>MET</a:t>
+            </a:r>
+          </a:p>
+        </p:txBody>
+      </p:sp>
+      <p:sp>
+        <p:nvSpPr>
+          <p:cNvPr id="13" name="TextBox 12"/>
           <p:cNvSpPr txBox="1"/>
           <p:nvPr/>
         </p:nvSpPr>
         <p:spPr>
           <a:xfrm>
-            <a:off x="4585716" y="1984248"/>
-            <a:ext cx="3108960" cy="640080"/>
-          </a:xfrm>
-          <a:prstGeom prst="rect">
-            <a:avLst/>
-          </a:prstGeom>
-          <a:noFill/>
-        </p:spPr>
-        <p:txBody>
-          <a:bodyPr wrap="square" lIns="0" tIns="0" rIns="0" bIns="0" anchor="t">
-            <a:noAutofit/>
-          </a:bodyPr>
-          <a:lstStyle/>
-          <a:p>
-            <a:pPr algn="l">
-              <a:spcBef>
-                <a:spcPts val="0"/>
-              </a:spcBef>
-              <a:spcAft>
-                <a:spcPts val="0"/>
-              </a:spcAft>
-            </a:pPr>
-            <a:r>
-              <a:rPr sz="3400" b="1" i="0" lang="en-GB">
-                <a:solidFill>
-                  <a:srgbClr val="0F2A44"/>
-                </a:solidFill>
-                <a:latin typeface="Aptos"/>
-                <a:ea typeface="Aptos"/>
-                <a:cs typeface="Dubai"/>
-              </a:rPr>
-              <a:t>10 points</a:t>
-            </a:r>
-          </a:p>
-        </p:txBody>
-      </p:sp>
-      <p:sp>
-        <p:nvSpPr>
-          <p:cNvPr id="16" name="TextBox 15"/>
-          <p:cNvSpPr txBox="1"/>
-          <p:nvPr/>
-        </p:nvSpPr>
-        <p:spPr>
-          <a:xfrm>
-            <a:off x="4585716" y="2651760"/>
-            <a:ext cx="3108960" cy="640080"/>
-          </a:xfrm>
-          <a:prstGeom prst="rect">
-            <a:avLst/>
-          </a:prstGeom>
-          <a:noFill/>
-        </p:spPr>
-        <p:txBody>
-          <a:bodyPr wrap="square" lIns="0" tIns="0" rIns="0" bIns="0" anchor="t">
-            <a:noAutofit/>
-          </a:bodyPr>
-          <a:lstStyle/>
-          <a:p>
-            <a:pPr algn="l">
-              <a:spcBef>
-                <a:spcPts val="0"/>
-              </a:spcBef>
-              <a:spcAft>
-                <a:spcPts val="0"/>
-              </a:spcAft>
-            </a:pPr>
-            <a:r>
-              <a:rPr sz="1400" b="0" i="0" lang="en-GB">
-                <a:solidFill>
-                  <a:srgbClr val="1F2937"/>
-                </a:solidFill>
-                <a:latin typeface="Aptos"/>
-                <a:ea typeface="Aptos"/>
-                <a:cs typeface="Dubai"/>
-              </a:rPr>
-              <a:t>the largest gap allowed between dialect and formal Arabic queries</a:t>
-            </a:r>
-          </a:p>
-        </p:txBody>
-      </p:sp>
-      <p:sp>
-        <p:nvSpPr>
-          <p:cNvPr id="17" name="Rounded Rectangle 16"/>
-          <p:cNvSpPr/>
-          <p:nvPr/>
-        </p:nvSpPr>
-        <p:spPr>
-          <a:xfrm>
-            <a:off x="8074152" y="1783080"/>
-            <a:ext cx="3566160" cy="1572768"/>
-          </a:xfrm>
-          <a:prstGeom prst="roundRect">
-            <a:avLst>
-              <a:gd name="adj" fmla="val 6000"/>
-            </a:avLst>
-          </a:prstGeom>
-          <a:solidFill>
-            <a:srgbClr val="F3F5F7"/>
-          </a:solidFill>
-          <a:ln>
-            <a:noFill/>
-          </a:ln>
-          <a:effectLst/>
-        </p:spPr>
-        <p:style>
-          <a:lnRef idx="1">
-            <a:schemeClr val="accent1"/>
-          </a:lnRef>
-          <a:fillRef idx="3">
-            <a:schemeClr val="accent1"/>
-          </a:fillRef>
-          <a:effectRef idx="2">
-            <a:schemeClr val="accent1"/>
-          </a:effectRef>
-          <a:fontRef idx="minor">
-            <a:schemeClr val="lt1"/>
-          </a:fontRef>
-        </p:style>
-        <p:txBody>
-          <a:bodyPr rtlCol="0" anchor="ctr"/>
-          <a:lstStyle/>
-          <a:p>
-            <a:pPr algn="ctr"/>
-          </a:p>
-        </p:txBody>
-      </p:sp>
-      <p:sp>
-        <p:nvSpPr>
-          <p:cNvPr id="18" name="Rectangle 17"/>
-          <p:cNvSpPr/>
-          <p:nvPr/>
-        </p:nvSpPr>
-        <p:spPr>
-          <a:xfrm>
-            <a:off x="8074152" y="2011680"/>
-            <a:ext cx="64008" cy="1115568"/>
-          </a:xfrm>
-          <a:prstGeom prst="rect">
-            <a:avLst/>
-          </a:prstGeom>
-          <a:solidFill>
-            <a:srgbClr val="0E7C7B"/>
-          </a:solidFill>
-          <a:ln>
-            <a:noFill/>
-          </a:ln>
-          <a:effectLst/>
-        </p:spPr>
-        <p:style>
-          <a:lnRef idx="1">
-            <a:schemeClr val="accent1"/>
-          </a:lnRef>
-          <a:fillRef idx="3">
-            <a:schemeClr val="accent1"/>
-          </a:fillRef>
-          <a:effectRef idx="2">
-            <a:schemeClr val="accent1"/>
-          </a:effectRef>
-          <a:fontRef idx="minor">
-            <a:schemeClr val="lt1"/>
-          </a:fontRef>
-        </p:style>
-        <p:txBody>
-          <a:bodyPr rtlCol="0" anchor="ctr"/>
-          <a:lstStyle/>
-          <a:p>
-            <a:pPr algn="ctr"/>
-          </a:p>
-        </p:txBody>
-      </p:sp>
-      <p:sp>
-        <p:nvSpPr>
-          <p:cNvPr id="19" name="TextBox 18"/>
-          <p:cNvSpPr txBox="1"/>
-          <p:nvPr/>
-        </p:nvSpPr>
-        <p:spPr>
-          <a:xfrm>
-            <a:off x="8348472" y="1984248"/>
-            <a:ext cx="3108960" cy="640080"/>
-          </a:xfrm>
-          <a:prstGeom prst="rect">
-            <a:avLst/>
-          </a:prstGeom>
-          <a:noFill/>
-        </p:spPr>
-        <p:txBody>
-          <a:bodyPr wrap="square" lIns="0" tIns="0" rIns="0" bIns="0" anchor="t">
-            <a:noAutofit/>
-          </a:bodyPr>
-          <a:lstStyle/>
-          <a:p>
-            <a:pPr algn="l">
-              <a:spcBef>
-                <a:spcPts val="0"/>
-              </a:spcBef>
-              <a:spcAft>
-                <a:spcPts val="0"/>
-              </a:spcAft>
-            </a:pPr>
-            <a:r>
-              <a:rPr sz="3400" b="1" i="0" lang="en-GB">
-                <a:solidFill>
-                  <a:srgbClr val="0F2A44"/>
-                </a:solidFill>
-                <a:latin typeface="Aptos"/>
-                <a:ea typeface="Aptos"/>
-                <a:cs typeface="Dubai"/>
-              </a:rPr>
-              <a:t>3 of 5</a:t>
-            </a:r>
-          </a:p>
-        </p:txBody>
-      </p:sp>
-      <p:sp>
-        <p:nvSpPr>
-          <p:cNvPr id="20" name="TextBox 19"/>
-          <p:cNvSpPr txBox="1"/>
-          <p:nvPr/>
-        </p:nvSpPr>
-        <p:spPr>
-          <a:xfrm>
-            <a:off x="8348472" y="2651760"/>
-            <a:ext cx="3108960" cy="640080"/>
-          </a:xfrm>
-          <a:prstGeom prst="rect">
-            <a:avLst/>
-          </a:prstGeom>
-          <a:noFill/>
-        </p:spPr>
-        <p:txBody>
-          <a:bodyPr wrap="square" lIns="0" tIns="0" rIns="0" bIns="0" anchor="t">
-            <a:noAutofit/>
-          </a:bodyPr>
-          <a:lstStyle/>
-          <a:p>
-            <a:pPr algn="l">
-              <a:spcBef>
-                <a:spcPts val="0"/>
-              </a:spcBef>
-              <a:spcAft>
-                <a:spcPts val="0"/>
-              </a:spcAft>
-            </a:pPr>
-            <a:r>
-              <a:rPr sz="1400" b="0" i="0" lang="en-GB">
-                <a:solidFill>
-                  <a:srgbClr val="1F2937"/>
-                </a:solidFill>
-                <a:latin typeface="Aptos"/>
-                <a:ea typeface="Aptos"/>
-                <a:cs typeface="Dubai"/>
-              </a:rPr>
-              <a:t>top results correct, on average</a:t>
-            </a:r>
-          </a:p>
-        </p:txBody>
-      </p:sp>
-      <p:sp>
-        <p:nvSpPr>
-          <p:cNvPr id="21" name="Rounded Rectangle 20"/>
-          <p:cNvSpPr/>
-          <p:nvPr/>
-        </p:nvSpPr>
-        <p:spPr>
-          <a:xfrm>
-            <a:off x="548640" y="3538728"/>
-            <a:ext cx="3566160" cy="1572768"/>
-          </a:xfrm>
-          <a:prstGeom prst="roundRect">
-            <a:avLst>
-              <a:gd name="adj" fmla="val 6000"/>
-            </a:avLst>
-          </a:prstGeom>
-          <a:solidFill>
-            <a:srgbClr val="F3F5F7"/>
-          </a:solidFill>
-          <a:ln>
-            <a:noFill/>
-          </a:ln>
-          <a:effectLst/>
-        </p:spPr>
-        <p:style>
-          <a:lnRef idx="1">
-            <a:schemeClr val="accent1"/>
-          </a:lnRef>
-          <a:fillRef idx="3">
-            <a:schemeClr val="accent1"/>
-          </a:fillRef>
-          <a:effectRef idx="2">
-            <a:schemeClr val="accent1"/>
-          </a:effectRef>
-          <a:fontRef idx="minor">
-            <a:schemeClr val="lt1"/>
-          </a:fontRef>
-        </p:style>
-        <p:txBody>
-          <a:bodyPr rtlCol="0" anchor="ctr"/>
-          <a:lstStyle/>
-          <a:p>
-            <a:pPr algn="ctr"/>
-          </a:p>
-        </p:txBody>
-      </p:sp>
-      <p:sp>
-        <p:nvSpPr>
-          <p:cNvPr id="22" name="Rectangle 21"/>
-          <p:cNvSpPr/>
-          <p:nvPr/>
-        </p:nvSpPr>
-        <p:spPr>
-          <a:xfrm>
-            <a:off x="548640" y="3767328"/>
-            <a:ext cx="64008" cy="1115568"/>
-          </a:xfrm>
-          <a:prstGeom prst="rect">
-            <a:avLst/>
-          </a:prstGeom>
-          <a:solidFill>
-            <a:srgbClr val="0E7C7B"/>
-          </a:solidFill>
-          <a:ln>
-            <a:noFill/>
-          </a:ln>
-          <a:effectLst/>
-        </p:spPr>
-        <p:style>
-          <a:lnRef idx="1">
-            <a:schemeClr val="accent1"/>
-          </a:lnRef>
-          <a:fillRef idx="3">
-            <a:schemeClr val="accent1"/>
-          </a:fillRef>
-          <a:effectRef idx="2">
-            <a:schemeClr val="accent1"/>
-          </a:effectRef>
-          <a:fontRef idx="minor">
-            <a:schemeClr val="lt1"/>
-          </a:fontRef>
-        </p:style>
-        <p:txBody>
-          <a:bodyPr rtlCol="0" anchor="ctr"/>
-          <a:lstStyle/>
-          <a:p>
-            <a:pPr algn="ctr"/>
-          </a:p>
-        </p:txBody>
-      </p:sp>
-      <p:sp>
-        <p:nvSpPr>
-          <p:cNvPr id="23" name="TextBox 22"/>
-          <p:cNvSpPr txBox="1"/>
-          <p:nvPr/>
-        </p:nvSpPr>
-        <p:spPr>
-          <a:xfrm>
-            <a:off x="822959" y="3739896"/>
-            <a:ext cx="3108960" cy="640080"/>
-          </a:xfrm>
-          <a:prstGeom prst="rect">
-            <a:avLst/>
-          </a:prstGeom>
-          <a:noFill/>
-        </p:spPr>
-        <p:txBody>
-          <a:bodyPr wrap="square" lIns="0" tIns="0" rIns="0" bIns="0" anchor="t">
-            <a:noAutofit/>
-          </a:bodyPr>
-          <a:lstStyle/>
-          <a:p>
-            <a:pPr algn="l">
-              <a:spcBef>
-                <a:spcPts val="0"/>
-              </a:spcBef>
-              <a:spcAft>
-                <a:spcPts val="0"/>
-              </a:spcAft>
-            </a:pPr>
-            <a:r>
-              <a:rPr sz="3400" b="1" i="0" lang="en-GB">
-                <a:solidFill>
-                  <a:srgbClr val="0F2A44"/>
-                </a:solidFill>
-                <a:latin typeface="Aptos"/>
-                <a:ea typeface="Aptos"/>
-                <a:cs typeface="Dubai"/>
-              </a:rPr>
-              <a:t>&lt; 20 min</a:t>
-            </a:r>
-          </a:p>
-        </p:txBody>
-      </p:sp>
-      <p:sp>
-        <p:nvSpPr>
-          <p:cNvPr id="24" name="TextBox 23"/>
-          <p:cNvSpPr txBox="1"/>
-          <p:nvPr/>
-        </p:nvSpPr>
-        <p:spPr>
-          <a:xfrm>
-            <a:off x="822959" y="4407408"/>
-            <a:ext cx="3108960" cy="640080"/>
-          </a:xfrm>
-          <a:prstGeom prst="rect">
-            <a:avLst/>
-          </a:prstGeom>
-          <a:noFill/>
-        </p:spPr>
-        <p:txBody>
-          <a:bodyPr wrap="square" lIns="0" tIns="0" rIns="0" bIns="0" anchor="t">
-            <a:noAutofit/>
-          </a:bodyPr>
-          <a:lstStyle/>
-          <a:p>
-            <a:pPr algn="l">
-              <a:spcBef>
-                <a:spcPts val="0"/>
-              </a:spcBef>
-              <a:spcAft>
-                <a:spcPts val="0"/>
-              </a:spcAft>
-            </a:pPr>
-            <a:r>
-              <a:rPr sz="1400" b="0" i="0" lang="en-GB">
-                <a:solidFill>
-                  <a:srgbClr val="1F2937"/>
-                </a:solidFill>
-                <a:latin typeface="Aptos"/>
-                <a:ea typeface="Aptos"/>
-                <a:cs typeface="Dubai"/>
-              </a:rPr>
-              <a:t>to index the demo clips on the Mac</a:t>
-            </a:r>
-          </a:p>
-        </p:txBody>
-      </p:sp>
-      <p:sp>
-        <p:nvSpPr>
-          <p:cNvPr id="25" name="Rounded Rectangle 24"/>
-          <p:cNvSpPr/>
-          <p:nvPr/>
-        </p:nvSpPr>
-        <p:spPr>
-          <a:xfrm>
-            <a:off x="4311396" y="3538728"/>
-            <a:ext cx="3566160" cy="1572768"/>
-          </a:xfrm>
-          <a:prstGeom prst="roundRect">
-            <a:avLst>
-              <a:gd name="adj" fmla="val 6000"/>
-            </a:avLst>
-          </a:prstGeom>
-          <a:solidFill>
-            <a:srgbClr val="F3F5F7"/>
-          </a:solidFill>
-          <a:ln>
-            <a:noFill/>
-          </a:ln>
-          <a:effectLst/>
-        </p:spPr>
-        <p:style>
-          <a:lnRef idx="1">
-            <a:schemeClr val="accent1"/>
-          </a:lnRef>
-          <a:fillRef idx="3">
-            <a:schemeClr val="accent1"/>
-          </a:fillRef>
-          <a:effectRef idx="2">
-            <a:schemeClr val="accent1"/>
-          </a:effectRef>
-          <a:fontRef idx="minor">
-            <a:schemeClr val="lt1"/>
-          </a:fontRef>
-        </p:style>
-        <p:txBody>
-          <a:bodyPr rtlCol="0" anchor="ctr"/>
-          <a:lstStyle/>
-          <a:p>
-            <a:pPr algn="ctr"/>
-          </a:p>
-        </p:txBody>
-      </p:sp>
-      <p:sp>
-        <p:nvSpPr>
-          <p:cNvPr id="26" name="Rectangle 25"/>
-          <p:cNvSpPr/>
-          <p:nvPr/>
-        </p:nvSpPr>
-        <p:spPr>
-          <a:xfrm>
-            <a:off x="4311396" y="3767328"/>
-            <a:ext cx="64008" cy="1115568"/>
-          </a:xfrm>
-          <a:prstGeom prst="rect">
-            <a:avLst/>
-          </a:prstGeom>
-          <a:solidFill>
-            <a:srgbClr val="0E7C7B"/>
-          </a:solidFill>
-          <a:ln>
-            <a:noFill/>
-          </a:ln>
-          <a:effectLst/>
-        </p:spPr>
-        <p:style>
-          <a:lnRef idx="1">
-            <a:schemeClr val="accent1"/>
-          </a:lnRef>
-          <a:fillRef idx="3">
-            <a:schemeClr val="accent1"/>
-          </a:fillRef>
-          <a:effectRef idx="2">
-            <a:schemeClr val="accent1"/>
-          </a:effectRef>
-          <a:fontRef idx="minor">
-            <a:schemeClr val="lt1"/>
-          </a:fontRef>
-        </p:style>
-        <p:txBody>
-          <a:bodyPr rtlCol="0" anchor="ctr"/>
-          <a:lstStyle/>
-          <a:p>
-            <a:pPr algn="ctr"/>
-          </a:p>
-        </p:txBody>
-      </p:sp>
-      <p:sp>
-        <p:nvSpPr>
-          <p:cNvPr id="27" name="TextBox 26"/>
-          <p:cNvSpPr txBox="1"/>
-          <p:nvPr/>
-        </p:nvSpPr>
-        <p:spPr>
-          <a:xfrm>
-            <a:off x="4585716" y="3739896"/>
-            <a:ext cx="3108960" cy="640080"/>
-          </a:xfrm>
-          <a:prstGeom prst="rect">
-            <a:avLst/>
-          </a:prstGeom>
-          <a:noFill/>
-        </p:spPr>
-        <p:txBody>
-          <a:bodyPr wrap="square" lIns="0" tIns="0" rIns="0" bIns="0" anchor="t">
-            <a:noAutofit/>
-          </a:bodyPr>
-          <a:lstStyle/>
-          <a:p>
-            <a:pPr algn="l">
-              <a:spcBef>
-                <a:spcPts val="0"/>
-              </a:spcBef>
-              <a:spcAft>
-                <a:spcPts val="0"/>
-              </a:spcAft>
-            </a:pPr>
-            <a:r>
-              <a:rPr sz="3400" b="1" i="0" lang="en-GB">
-                <a:solidFill>
-                  <a:srgbClr val="0F2A44"/>
-                </a:solidFill>
-                <a:latin typeface="Aptos"/>
-                <a:ea typeface="Aptos"/>
-                <a:cs typeface="Dubai"/>
-              </a:rPr>
-              <a:t>&lt; 5 s</a:t>
-            </a:r>
-          </a:p>
-        </p:txBody>
-      </p:sp>
-      <p:sp>
-        <p:nvSpPr>
-          <p:cNvPr id="28" name="TextBox 27"/>
-          <p:cNvSpPr txBox="1"/>
-          <p:nvPr/>
-        </p:nvSpPr>
-        <p:spPr>
-          <a:xfrm>
-            <a:off x="4585716" y="4407408"/>
-            <a:ext cx="3108960" cy="640080"/>
-          </a:xfrm>
-          <a:prstGeom prst="rect">
-            <a:avLst/>
-          </a:prstGeom>
-          <a:noFill/>
-        </p:spPr>
-        <p:txBody>
-          <a:bodyPr wrap="square" lIns="0" tIns="0" rIns="0" bIns="0" anchor="t">
-            <a:noAutofit/>
-          </a:bodyPr>
-          <a:lstStyle/>
-          <a:p>
-            <a:pPr algn="l">
-              <a:spcBef>
-                <a:spcPts val="0"/>
-              </a:spcBef>
-              <a:spcAft>
-                <a:spcPts val="0"/>
-              </a:spcAft>
-            </a:pPr>
-            <a:r>
-              <a:rPr sz="1400" b="0" i="0" lang="en-GB">
-                <a:solidFill>
-                  <a:srgbClr val="1F2937"/>
-                </a:solidFill>
-                <a:latin typeface="Aptos"/>
-                <a:ea typeface="Aptos"/>
-                <a:cs typeface="Dubai"/>
-              </a:rPr>
-              <a:t>until results appear; double-checks fill in after</a:t>
-            </a:r>
-          </a:p>
-        </p:txBody>
-      </p:sp>
-      <p:sp>
-        <p:nvSpPr>
-          <p:cNvPr id="29" name="Rounded Rectangle 28"/>
-          <p:cNvSpPr/>
-          <p:nvPr/>
-        </p:nvSpPr>
-        <p:spPr>
-          <a:xfrm>
-            <a:off x="8074152" y="3538728"/>
-            <a:ext cx="3566160" cy="1572768"/>
-          </a:xfrm>
-          <a:prstGeom prst="roundRect">
-            <a:avLst>
-              <a:gd name="adj" fmla="val 6000"/>
-            </a:avLst>
-          </a:prstGeom>
-          <a:solidFill>
-            <a:srgbClr val="F3F5F7"/>
-          </a:solidFill>
-          <a:ln>
-            <a:noFill/>
-          </a:ln>
-          <a:effectLst/>
-        </p:spPr>
-        <p:style>
-          <a:lnRef idx="1">
-            <a:schemeClr val="accent1"/>
-          </a:lnRef>
-          <a:fillRef idx="3">
-            <a:schemeClr val="accent1"/>
-          </a:fillRef>
-          <a:effectRef idx="2">
-            <a:schemeClr val="accent1"/>
-          </a:effectRef>
-          <a:fontRef idx="minor">
-            <a:schemeClr val="lt1"/>
-          </a:fontRef>
-        </p:style>
-        <p:txBody>
-          <a:bodyPr rtlCol="0" anchor="ctr"/>
-          <a:lstStyle/>
-          <a:p>
-            <a:pPr algn="ctr"/>
-          </a:p>
-        </p:txBody>
-      </p:sp>
-      <p:sp>
-        <p:nvSpPr>
-          <p:cNvPr id="30" name="Rectangle 29"/>
-          <p:cNvSpPr/>
-          <p:nvPr/>
-        </p:nvSpPr>
-        <p:spPr>
-          <a:xfrm>
-            <a:off x="8074152" y="3767328"/>
-            <a:ext cx="64008" cy="1115568"/>
-          </a:xfrm>
-          <a:prstGeom prst="rect">
-            <a:avLst/>
-          </a:prstGeom>
-          <a:solidFill>
-            <a:srgbClr val="0E7C7B"/>
-          </a:solidFill>
-          <a:ln>
-            <a:noFill/>
-          </a:ln>
-          <a:effectLst/>
-        </p:spPr>
-        <p:style>
-          <a:lnRef idx="1">
-            <a:schemeClr val="accent1"/>
-          </a:lnRef>
-          <a:fillRef idx="3">
-            <a:schemeClr val="accent1"/>
-          </a:fillRef>
-          <a:effectRef idx="2">
-            <a:schemeClr val="accent1"/>
-          </a:effectRef>
-          <a:fontRef idx="minor">
-            <a:schemeClr val="lt1"/>
-          </a:fontRef>
-        </p:style>
-        <p:txBody>
-          <a:bodyPr rtlCol="0" anchor="ctr"/>
-          <a:lstStyle/>
-          <a:p>
-            <a:pPr algn="ctr"/>
-          </a:p>
-        </p:txBody>
-      </p:sp>
-      <p:sp>
-        <p:nvSpPr>
-          <p:cNvPr id="31" name="TextBox 30"/>
-          <p:cNvSpPr txBox="1"/>
-          <p:nvPr/>
-        </p:nvSpPr>
-        <p:spPr>
-          <a:xfrm>
-            <a:off x="8348472" y="3739896"/>
-            <a:ext cx="3108960" cy="640080"/>
-          </a:xfrm>
-          <a:prstGeom prst="rect">
-            <a:avLst/>
-          </a:prstGeom>
-          <a:noFill/>
-        </p:spPr>
-        <p:txBody>
-          <a:bodyPr wrap="square" lIns="0" tIns="0" rIns="0" bIns="0" anchor="t">
-            <a:noAutofit/>
-          </a:bodyPr>
-          <a:lstStyle/>
-          <a:p>
-            <a:pPr algn="l">
-              <a:spcBef>
-                <a:spcPts val="0"/>
-              </a:spcBef>
-              <a:spcAft>
-                <a:spcPts val="0"/>
-              </a:spcAft>
-            </a:pPr>
-            <a:r>
-              <a:rPr sz="3400" b="1" i="0" lang="en-GB">
-                <a:solidFill>
-                  <a:srgbClr val="0F2A44"/>
-                </a:solidFill>
-                <a:latin typeface="Aptos"/>
-                <a:ea typeface="Aptos"/>
-                <a:cs typeface="Dubai"/>
-              </a:rPr>
-              <a:t>&lt; 2 min</a:t>
-            </a:r>
-          </a:p>
-        </p:txBody>
-      </p:sp>
-      <p:sp>
-        <p:nvSpPr>
-          <p:cNvPr id="32" name="TextBox 31"/>
-          <p:cNvSpPr txBox="1"/>
-          <p:nvPr/>
-        </p:nvSpPr>
-        <p:spPr>
-          <a:xfrm>
-            <a:off x="8348472" y="4407408"/>
-            <a:ext cx="3108960" cy="640080"/>
-          </a:xfrm>
-          <a:prstGeom prst="rect">
-            <a:avLst/>
-          </a:prstGeom>
-          <a:noFill/>
-        </p:spPr>
-        <p:txBody>
-          <a:bodyPr wrap="square" lIns="0" tIns="0" rIns="0" bIns="0" anchor="t">
-            <a:noAutofit/>
-          </a:bodyPr>
-          <a:lstStyle/>
-          <a:p>
-            <a:pPr algn="l">
-              <a:spcBef>
-                <a:spcPts val="0"/>
-              </a:spcBef>
-              <a:spcAft>
-                <a:spcPts val="0"/>
-              </a:spcAft>
-            </a:pPr>
-            <a:r>
-              <a:rPr sz="1400" b="0" i="0" lang="en-GB">
-                <a:solidFill>
-                  <a:srgbClr val="1F2937"/>
-                </a:solidFill>
-                <a:latin typeface="Aptos"/>
-                <a:ea typeface="Aptos"/>
-                <a:cs typeface="Dubai"/>
-              </a:rPr>
-              <a:t>for an officer to find the target of each story</a:t>
-            </a:r>
-          </a:p>
-        </p:txBody>
-      </p:sp>
-      <p:sp>
-        <p:nvSpPr>
-          <p:cNvPr id="33" name="Rounded Rectangle 32"/>
-          <p:cNvSpPr/>
-          <p:nvPr/>
-        </p:nvSpPr>
-        <p:spPr>
-          <a:xfrm>
-            <a:off x="548640" y="5394960"/>
-            <a:ext cx="11091672" cy="822960"/>
-          </a:xfrm>
-          <a:prstGeom prst="roundRect">
-            <a:avLst>
-              <a:gd name="adj" fmla="val 8000"/>
-            </a:avLst>
-          </a:prstGeom>
-          <a:solidFill>
-            <a:srgbClr val="FDF1E1"/>
-          </a:solidFill>
-          <a:ln>
-            <a:noFill/>
-          </a:ln>
-          <a:effectLst/>
-        </p:spPr>
-        <p:style>
-          <a:lnRef idx="1">
-            <a:schemeClr val="accent1"/>
-          </a:lnRef>
-          <a:fillRef idx="3">
-            <a:schemeClr val="accent1"/>
-          </a:fillRef>
-          <a:effectRef idx="2">
-            <a:schemeClr val="accent1"/>
-          </a:effectRef>
-          <a:fontRef idx="minor">
-            <a:schemeClr val="lt1"/>
-          </a:fontRef>
-        </p:style>
-        <p:txBody>
-          <a:bodyPr rtlCol="0" anchor="ctr" wrap="square" lIns="201168" tIns="160934" rIns="201168" bIns="160934">
-            <a:noAutofit/>
-          </a:bodyPr>
-          <a:lstStyle/>
-          <a:p>
-            <a:pPr algn="l">
-              <a:spcBef>
-                <a:spcPts val="0"/>
-              </a:spcBef>
-              <a:spcAft>
-                <a:spcPts val="0"/>
-              </a:spcAft>
-            </a:pPr>
-            <a:r>
-              <a:rPr sz="1400" b="1" i="0" lang="en-GB">
-                <a:solidFill>
-                  <a:srgbClr val="B45F06"/>
-                </a:solidFill>
-                <a:latin typeface="Aptos"/>
-                <a:ea typeface="Aptos"/>
-                <a:cs typeface="Dubai"/>
-              </a:rPr>
-              <a:t>Main risk: </a:t>
-            </a:r>
-            <a:r>
-              <a:rPr sz="1400" b="0" i="0" lang="en-GB">
-                <a:solidFill>
-                  <a:srgbClr val="1F2937"/>
-                </a:solidFill>
-                <a:latin typeface="Aptos"/>
-                <a:ea typeface="Aptos"/>
-                <a:cs typeface="Dubai"/>
-              </a:rPr>
-              <a:t>no public test exists for Jordanian or Gulf Arabic descriptions against video, so we write our own set of about 100 test queries, checked by a native speaker.</a:t>
-            </a:r>
-          </a:p>
-        </p:txBody>
-      </p:sp>
-    </p:spTree>
-  </p:cSld>
-  <p:clrMapOvr>
-    <a:masterClrMapping/>
-  </p:clrMapOvr>
-</p:sld>
-</file>
-
-<file path=ppt/slides/slide13.xml><?xml version="1.0" encoding="utf-8"?>
-<p:sld xmlns:a="http://schemas.openxmlformats.org/drawingml/2006/main" xmlns:p="http://schemas.openxmlformats.org/presentationml/2006/main" xmlns:r="http://schemas.openxmlformats.org/officeDocument/2006/relationships">
-  <p:cSld>
-    <p:bg>
-      <p:bgPr>
-        <a:solidFill>
-          <a:srgbClr val="FFFFFF"/>
-        </a:solidFill>
-        <a:effectLst/>
-      </p:bgPr>
-    </p:bg>
-    <p:spTree>
-      <p:nvGrpSpPr>
-        <p:cNvPr id="1" name=""/>
-        <p:cNvGrpSpPr/>
-        <p:nvPr/>
-      </p:nvGrpSpPr>
-      <p:grpSpPr/>
-      <p:sp>
-        <p:nvSpPr>
-          <p:cNvPr id="2" name="Rectangle 1"/>
-          <p:cNvSpPr/>
-          <p:nvPr/>
-        </p:nvSpPr>
-        <p:spPr>
-          <a:xfrm>
-            <a:off x="0" y="0"/>
-            <a:ext cx="12191695" cy="109728"/>
-          </a:xfrm>
-          <a:prstGeom prst="rect">
-            <a:avLst/>
-          </a:prstGeom>
-          <a:solidFill>
-            <a:srgbClr val="0E7C7B"/>
-          </a:solidFill>
-          <a:ln>
-            <a:noFill/>
-          </a:ln>
-          <a:effectLst/>
-        </p:spPr>
-        <p:style>
-          <a:lnRef idx="1">
-            <a:schemeClr val="accent1"/>
-          </a:lnRef>
-          <a:fillRef idx="3">
-            <a:schemeClr val="accent1"/>
-          </a:fillRef>
-          <a:effectRef idx="2">
-            <a:schemeClr val="accent1"/>
-          </a:effectRef>
-          <a:fontRef idx="minor">
-            <a:schemeClr val="lt1"/>
-          </a:fontRef>
-        </p:style>
-        <p:txBody>
-          <a:bodyPr rtlCol="0" anchor="ctr"/>
-          <a:lstStyle/>
-          <a:p>
-            <a:pPr algn="ctr"/>
-          </a:p>
-        </p:txBody>
-      </p:sp>
-      <p:cxnSp>
-        <p:nvCxnSpPr>
-          <p:cNvPr id="3" name="Connector 2"/>
-          <p:cNvCxnSpPr/>
-          <p:nvPr/>
-        </p:nvCxnSpPr>
-        <p:spPr>
-          <a:xfrm>
-            <a:off x="548640" y="6419088"/>
-            <a:ext cx="11094415" cy="0"/>
-          </a:xfrm>
-          <a:prstGeom prst="line">
-            <a:avLst/>
-          </a:prstGeom>
-          <a:ln w="12700">
-            <a:solidFill>
-              <a:srgbClr val="D5DBE1"/>
-            </a:solidFill>
-          </a:ln>
-        </p:spPr>
-      </p:cxnSp>
-      <p:sp>
-        <p:nvSpPr>
-          <p:cNvPr id="4" name="TextBox 3"/>
-          <p:cNvSpPr txBox="1"/>
-          <p:nvPr/>
-        </p:nvSpPr>
-        <p:spPr>
-          <a:xfrm>
-            <a:off x="548640" y="6473952"/>
-            <a:ext cx="7315200" cy="274320"/>
-          </a:xfrm>
-          <a:prstGeom prst="rect">
-            <a:avLst/>
-          </a:prstGeom>
-          <a:noFill/>
-        </p:spPr>
-        <p:txBody>
-          <a:bodyPr wrap="square" lIns="0" tIns="0" rIns="0" bIns="0" anchor="t">
-            <a:noAutofit/>
-          </a:bodyPr>
-          <a:lstStyle/>
-          <a:p>
-            <a:pPr algn="l">
-              <a:spcBef>
-                <a:spcPts val="0"/>
-              </a:spcBef>
-              <a:spcAft>
-                <a:spcPts val="0"/>
-              </a:spcAft>
-            </a:pPr>
-            <a:r>
-              <a:rPr sz="1000" b="0" i="0" lang="en-GB">
-                <a:solidFill>
-                  <a:srgbClr val="5B6573"/>
-                </a:solidFill>
-                <a:latin typeface="Aptos"/>
-                <a:ea typeface="Aptos"/>
-                <a:cs typeface="Dubai"/>
-              </a:rPr>
-              <a:t>Arabic AI Video Search  ·  PoC use cases</a:t>
-            </a:r>
-          </a:p>
-        </p:txBody>
-      </p:sp>
-      <p:sp>
-        <p:nvSpPr>
-          <p:cNvPr id="5" name="TextBox 4"/>
-          <p:cNvSpPr txBox="1"/>
-          <p:nvPr/>
-        </p:nvSpPr>
-        <p:spPr>
-          <a:xfrm>
-            <a:off x="9814255" y="6473952"/>
-            <a:ext cx="1828800" cy="274320"/>
-          </a:xfrm>
-          <a:prstGeom prst="rect">
-            <a:avLst/>
-          </a:prstGeom>
-          <a:noFill/>
-        </p:spPr>
-        <p:txBody>
-          <a:bodyPr wrap="square" lIns="0" tIns="0" rIns="0" bIns="0" anchor="t">
-            <a:noAutofit/>
-          </a:bodyPr>
-          <a:lstStyle/>
-          <a:p>
-            <a:pPr algn="r">
-              <a:spcBef>
-                <a:spcPts val="0"/>
-              </a:spcBef>
-              <a:spcAft>
-                <a:spcPts val="0"/>
-              </a:spcAft>
-            </a:pPr>
-            <a:r>
-              <a:rPr sz="1000" b="0" i="0" lang="en-GB">
-                <a:solidFill>
-                  <a:srgbClr val="5B6573"/>
-                </a:solidFill>
-                <a:latin typeface="Aptos"/>
-                <a:ea typeface="Aptos"/>
-                <a:cs typeface="Dubai"/>
-              </a:rPr>
-              <a:t>13 / 13</a:t>
-            </a:r>
-          </a:p>
-        </p:txBody>
-      </p:sp>
-      <p:sp>
-        <p:nvSpPr>
-          <p:cNvPr id="6" name="TextBox 5"/>
-          <p:cNvSpPr txBox="1"/>
-          <p:nvPr/>
-        </p:nvSpPr>
-        <p:spPr>
-          <a:xfrm>
-            <a:off x="548640" y="347472"/>
-            <a:ext cx="7680960" cy="292608"/>
-          </a:xfrm>
-          <a:prstGeom prst="rect">
-            <a:avLst/>
-          </a:prstGeom>
-          <a:noFill/>
-        </p:spPr>
-        <p:txBody>
-          <a:bodyPr wrap="square" lIns="0" tIns="0" rIns="0" bIns="0" anchor="t">
-            <a:noAutofit/>
-          </a:bodyPr>
-          <a:lstStyle/>
-          <a:p>
-            <a:pPr algn="l">
-              <a:spcBef>
-                <a:spcPts val="0"/>
-              </a:spcBef>
-              <a:spcAft>
-                <a:spcPts val="0"/>
-              </a:spcAft>
-            </a:pPr>
-            <a:r>
-              <a:rPr sz="1200" b="1" i="0" lang="en-GB">
-                <a:solidFill>
-                  <a:srgbClr val="0E7C7B"/>
-                </a:solidFill>
-                <a:latin typeface="Aptos"/>
-                <a:ea typeface="Aptos"/>
-                <a:cs typeface="Dubai"/>
-              </a:rPr>
-              <a:t>ROADMAP</a:t>
-            </a:r>
-          </a:p>
-        </p:txBody>
-      </p:sp>
-      <p:sp>
-        <p:nvSpPr>
-          <p:cNvPr id="7" name="TextBox 6"/>
-          <p:cNvSpPr txBox="1"/>
-          <p:nvPr/>
-        </p:nvSpPr>
-        <p:spPr>
-          <a:xfrm>
-            <a:off x="7802575" y="274320"/>
-            <a:ext cx="3840480" cy="411480"/>
-          </a:xfrm>
-          <a:prstGeom prst="rect">
-            <a:avLst/>
-          </a:prstGeom>
-          <a:noFill/>
-        </p:spPr>
-        <p:txBody>
-          <a:bodyPr wrap="square" lIns="0" tIns="0" rIns="0" bIns="0" anchor="t">
-            <a:noAutofit/>
-          </a:bodyPr>
-          <a:lstStyle/>
-          <a:p>
-            <a:pPr algn="r" rtl="1">
-              <a:spcBef>
-                <a:spcPts val="0"/>
-              </a:spcBef>
-              <a:spcAft>
-                <a:spcPts val="0"/>
-              </a:spcAft>
-            </a:pPr>
-            <a:r>
-              <a:rPr sz="1800" b="1" i="0" lang="ar-JO">
-                <a:solidFill>
-                  <a:srgbClr val="0E7C7B"/>
-                </a:solidFill>
-                <a:latin typeface="Aptos"/>
-                <a:ea typeface="Aptos"/>
-                <a:cs typeface="Dubai"/>
-              </a:rPr>
-              <a:t>خارطة الطريق</a:t>
-            </a:r>
-          </a:p>
-        </p:txBody>
-      </p:sp>
-      <p:sp>
-        <p:nvSpPr>
-          <p:cNvPr id="8" name="TextBox 7"/>
-          <p:cNvSpPr txBox="1"/>
-          <p:nvPr/>
-        </p:nvSpPr>
-        <p:spPr>
-          <a:xfrm>
-            <a:off x="548640" y="658368"/>
-            <a:ext cx="11064240" cy="914400"/>
+            <a:off x="822959" y="2304288"/>
+            <a:ext cx="3108960" cy="438912"/>
           </a:xfrm>
           <a:prstGeom prst="rect">
             <a:avLst/>
@@ -13173,139 +11881,29 @@
               </a:spcAft>
             </a:pPr>
             <a:r>
-              <a:rPr sz="2800" b="1" i="0" lang="en-GB">
-                <a:solidFill>
-                  <a:srgbClr val="0F2A44"/>
-                </a:solidFill>
-                <a:latin typeface="Aptos"/>
-                <a:ea typeface="Aptos"/>
-                <a:cs typeface="Dubai"/>
-              </a:rPr>
-              <a:t>Four phases to a working demo, then a pilot with a partner site</a:t>
-            </a:r>
-          </a:p>
-        </p:txBody>
-      </p:sp>
-      <p:sp>
-        <p:nvSpPr>
-          <p:cNvPr id="9" name="Rounded Rectangle 8"/>
-          <p:cNvSpPr/>
-          <p:nvPr/>
-        </p:nvSpPr>
-        <p:spPr>
-          <a:xfrm>
-            <a:off x="548640" y="1783080"/>
-            <a:ext cx="2635758" cy="566928"/>
-          </a:xfrm>
-          <a:prstGeom prst="roundRect">
-            <a:avLst>
-              <a:gd name="adj" fmla="val 12000"/>
-            </a:avLst>
-          </a:prstGeom>
-          <a:solidFill>
-            <a:srgbClr val="0E7C7B"/>
-          </a:solidFill>
-          <a:ln>
-            <a:noFill/>
-          </a:ln>
-          <a:effectLst/>
-        </p:spPr>
-        <p:style>
-          <a:lnRef idx="1">
-            <a:schemeClr val="accent1"/>
-          </a:lnRef>
-          <a:fillRef idx="3">
-            <a:schemeClr val="accent1"/>
-          </a:fillRef>
-          <a:effectRef idx="2">
-            <a:schemeClr val="accent1"/>
-          </a:effectRef>
-          <a:fontRef idx="minor">
-            <a:schemeClr val="lt1"/>
-          </a:fontRef>
-        </p:style>
-        <p:txBody>
-          <a:bodyPr rtlCol="0" anchor="ctr" wrap="square" lIns="36576" tIns="29260" rIns="36576" bIns="29260">
-            <a:noAutofit/>
-          </a:bodyPr>
-          <a:lstStyle/>
-          <a:p>
-            <a:pPr algn="ctr">
-              <a:spcBef>
-                <a:spcPts val="0"/>
-              </a:spcBef>
-              <a:spcAft>
-                <a:spcPts val="0"/>
-              </a:spcAft>
-            </a:pPr>
-            <a:r>
-              <a:rPr sz="1300" b="1" i="0" lang="en-GB">
-                <a:solidFill>
-                  <a:srgbClr val="FFFFFF"/>
-                </a:solidFill>
-                <a:latin typeface="Aptos"/>
-                <a:ea typeface="Aptos"/>
-                <a:cs typeface="Dubai"/>
-              </a:rPr>
-              <a:t>Phase 0</a:t>
-            </a:r>
-          </a:p>
-        </p:txBody>
-      </p:sp>
-      <p:sp>
-        <p:nvSpPr>
-          <p:cNvPr id="10" name="Chevron 9"/>
-          <p:cNvSpPr/>
-          <p:nvPr/>
-        </p:nvSpPr>
-        <p:spPr>
-          <a:xfrm>
-            <a:off x="3211830" y="1947672"/>
-            <a:ext cx="128016" cy="237744"/>
-          </a:xfrm>
-          <a:prstGeom prst="chevron">
-            <a:avLst/>
-          </a:prstGeom>
-          <a:solidFill>
-            <a:srgbClr val="D5DBE1"/>
-          </a:solidFill>
-          <a:ln>
-            <a:noFill/>
-          </a:ln>
-          <a:effectLst/>
-        </p:spPr>
-        <p:style>
-          <a:lnRef idx="1">
-            <a:schemeClr val="accent1"/>
-          </a:lnRef>
-          <a:fillRef idx="3">
-            <a:schemeClr val="accent1"/>
-          </a:fillRef>
-          <a:effectRef idx="2">
-            <a:schemeClr val="accent1"/>
-          </a:effectRef>
-          <a:fontRef idx="minor">
-            <a:schemeClr val="lt1"/>
-          </a:fontRef>
-        </p:style>
-        <p:txBody>
-          <a:bodyPr rtlCol="0" anchor="ctr"/>
-          <a:lstStyle/>
-          <a:p>
-            <a:pPr algn="ctr"/>
-          </a:p>
-        </p:txBody>
-      </p:sp>
-      <p:sp>
-        <p:nvSpPr>
-          <p:cNvPr id="11" name="TextBox 10"/>
+              <a:rPr sz="1200" b="0" i="0" lang="en-GB">
+                <a:solidFill>
+                  <a:srgbClr val="5B6573"/>
+                </a:solidFill>
+                <a:latin typeface="Aptos"/>
+                <a:ea typeface="Aptos"/>
+                <a:cs typeface="Dubai"/>
+              </a:rPr>
+              <a:t>of test queries find the right person in the top 10</a:t>
+            </a:r>
+          </a:p>
+        </p:txBody>
+      </p:sp>
+      <p:sp>
+        <p:nvSpPr>
+          <p:cNvPr id="14" name="TextBox 13"/>
           <p:cNvSpPr txBox="1"/>
           <p:nvPr/>
         </p:nvSpPr>
         <p:spPr>
           <a:xfrm>
-            <a:off x="548640" y="2514600"/>
-            <a:ext cx="2635758" cy="365760"/>
+            <a:off x="822959" y="2743200"/>
+            <a:ext cx="3108960" cy="640080"/>
           </a:xfrm>
           <a:prstGeom prst="rect">
             <a:avLst/>
@@ -13319,6 +11917,9 @@
           <a:lstStyle/>
           <a:p>
             <a:pPr algn="l">
+              <a:lnSpc>
+                <a:spcPct val="95000"/>
+              </a:lnSpc>
               <a:spcBef>
                 <a:spcPts val="0"/>
               </a:spcBef>
@@ -13327,29 +11928,130 @@
               </a:spcAft>
             </a:pPr>
             <a:r>
-              <a:rPr sz="1800" b="1" i="0" lang="en-GB">
-                <a:solidFill>
-                  <a:srgbClr val="0F2A44"/>
-                </a:solidFill>
-                <a:latin typeface="Aptos"/>
-                <a:ea typeface="Aptos"/>
-                <a:cs typeface="Dubai"/>
-              </a:rPr>
-              <a:t>Set-up</a:t>
-            </a:r>
-          </a:p>
-        </p:txBody>
-      </p:sp>
-      <p:sp>
-        <p:nvSpPr>
-          <p:cNvPr id="12" name="TextBox 11"/>
+              <a:rPr sz="1250" b="1" i="0" lang="en-GB">
+                <a:solidFill>
+                  <a:srgbClr val="0E7C7B"/>
+                </a:solidFill>
+                <a:latin typeface="Aptos"/>
+                <a:ea typeface="Aptos"/>
+                <a:cs typeface="Dubai"/>
+              </a:rPr>
+              <a:t>Measured: </a:t>
+            </a:r>
+            <a:r>
+              <a:rPr sz="1250" b="0" i="0" lang="en-GB">
+                <a:solidFill>
+                  <a:srgbClr val="1F2937"/>
+                </a:solidFill>
+                <a:latin typeface="Aptos"/>
+                <a:ea typeface="Aptos"/>
+                <a:cs typeface="Dubai"/>
+              </a:rPr>
+              <a:t>99% with phase 2, 91% with option A. 98% on the 63 queries written after tuning.</a:t>
+            </a:r>
+          </a:p>
+        </p:txBody>
+      </p:sp>
+      <p:sp>
+        <p:nvSpPr>
+          <p:cNvPr id="15" name="Rounded Rectangle 14"/>
+          <p:cNvSpPr/>
+          <p:nvPr/>
+        </p:nvSpPr>
+        <p:spPr>
+          <a:xfrm>
+            <a:off x="4311396" y="1737360"/>
+            <a:ext cx="3566160" cy="1719072"/>
+          </a:xfrm>
+          <a:prstGeom prst="roundRect">
+            <a:avLst>
+              <a:gd name="adj" fmla="val 6000"/>
+            </a:avLst>
+          </a:prstGeom>
+          <a:solidFill>
+            <a:srgbClr val="F3F5F7"/>
+          </a:solidFill>
+          <a:ln>
+            <a:noFill/>
+          </a:ln>
+          <a:effectLst/>
+        </p:spPr>
+        <p:style>
+          <a:lnRef idx="1">
+            <a:schemeClr val="accent1"/>
+          </a:lnRef>
+          <a:fillRef idx="3">
+            <a:schemeClr val="accent1"/>
+          </a:fillRef>
+          <a:effectRef idx="2">
+            <a:schemeClr val="accent1"/>
+          </a:effectRef>
+          <a:fontRef idx="minor">
+            <a:schemeClr val="lt1"/>
+          </a:fontRef>
+        </p:style>
+        <p:txBody>
+          <a:bodyPr rtlCol="0" anchor="ctr"/>
+          <a:lstStyle/>
+          <a:p>
+            <a:pPr algn="ctr"/>
+          </a:p>
+        </p:txBody>
+      </p:sp>
+      <p:sp>
+        <p:nvSpPr>
+          <p:cNvPr id="16" name="Rectangle 15"/>
+          <p:cNvSpPr/>
+          <p:nvPr/>
+        </p:nvSpPr>
+        <p:spPr>
+          <a:xfrm>
+            <a:off x="4311396" y="1920240"/>
+            <a:ext cx="64008" cy="1353312"/>
+          </a:xfrm>
+          <a:prstGeom prst="rect">
+            <a:avLst/>
+          </a:prstGeom>
+          <a:solidFill>
+            <a:srgbClr val="0E7C7B"/>
+          </a:solidFill>
+          <a:ln>
+            <a:noFill/>
+          </a:ln>
+          <a:effectLst/>
+        </p:spPr>
+        <p:style>
+          <a:lnRef idx="1">
+            <a:schemeClr val="accent1"/>
+          </a:lnRef>
+          <a:fillRef idx="3">
+            <a:schemeClr val="accent1"/>
+          </a:fillRef>
+          <a:effectRef idx="2">
+            <a:schemeClr val="accent1"/>
+          </a:effectRef>
+          <a:fontRef idx="minor">
+            <a:schemeClr val="lt1"/>
+          </a:fontRef>
+        </p:style>
+        <p:txBody>
+          <a:bodyPr rtlCol="0" anchor="ctr"/>
+          <a:lstStyle/>
+          <a:p>
+            <a:pPr algn="ctr"/>
+          </a:p>
+        </p:txBody>
+      </p:sp>
+      <p:sp>
+        <p:nvSpPr>
+          <p:cNvPr id="17" name="TextBox 16"/>
           <p:cNvSpPr txBox="1"/>
           <p:nvPr/>
         </p:nvSpPr>
         <p:spPr>
           <a:xfrm>
-            <a:off x="548640" y="2880360"/>
-            <a:ext cx="2635758" cy="868680"/>
+            <a:off x="4585716" y="1865376"/>
+            <a:ext cx="2011680" cy="457200"/>
           </a:xfrm>
           <a:prstGeom prst="rect">
             <a:avLst/>
@@ -13371,59 +12073,61 @@
               </a:spcAft>
             </a:pPr>
             <a:r>
-              <a:rPr sz="1350" b="0" i="0" lang="en-GB">
-                <a:solidFill>
-                  <a:srgbClr val="1F2937"/>
-                </a:solidFill>
-                <a:latin typeface="Aptos"/>
-                <a:ea typeface="Aptos"/>
-                <a:cs typeface="Dubai"/>
-              </a:rPr>
-              <a:t>Mac ready, about 10 public clips trimmed, right answers written down.</a:t>
-            </a:r>
-          </a:p>
-        </p:txBody>
-      </p:sp>
-      <p:sp>
-        <p:nvSpPr>
-          <p:cNvPr id="13" name="Rounded Rectangle 12"/>
-          <p:cNvSpPr/>
-          <p:nvPr/>
-        </p:nvSpPr>
-        <p:spPr>
-          <a:xfrm>
-            <a:off x="3367278" y="1783080"/>
-            <a:ext cx="2635758" cy="566928"/>
+              <a:rPr sz="2600" b="1" i="0" lang="en-GB">
+                <a:solidFill>
+                  <a:srgbClr val="0F2A44"/>
+                </a:solidFill>
+                <a:latin typeface="Aptos"/>
+                <a:ea typeface="Aptos"/>
+                <a:cs typeface="Dubai"/>
+              </a:rPr>
+              <a:t>10 points</a:t>
+            </a:r>
+          </a:p>
+        </p:txBody>
+      </p:sp>
+      <p:sp>
+        <p:nvSpPr>
+          <p:cNvPr id="18" name="Rounded Rectangle 17"/>
+          <p:cNvSpPr/>
+          <p:nvPr/>
+        </p:nvSpPr>
+        <p:spPr>
+          <a:xfrm>
+            <a:off x="6825996" y="1920240"/>
+            <a:ext cx="868680" cy="274320"/>
           </a:xfrm>
           <a:prstGeom prst="roundRect">
             <a:avLst>
-              <a:gd name="adj" fmla="val 12000"/>
+              <a:gd name="adj" fmla="val 50000"/>
             </a:avLst>
           </a:prstGeom>
           <a:solidFill>
-            <a:srgbClr val="0E7C7B"/>
-          </a:solidFill>
-          <a:ln>
-            <a:noFill/>
-          </a:ln>
-          <a:effectLst/>
-        </p:spPr>
-        <p:style>
-          <a:lnRef idx="1">
-            <a:schemeClr val="accent1"/>
-          </a:lnRef>
-          <a:fillRef idx="3">
-            <a:schemeClr val="accent1"/>
-          </a:fillRef>
-          <a:effectRef idx="2">
-            <a:schemeClr val="accent1"/>
-          </a:effectRef>
-          <a:fontRef idx="minor">
-            <a:schemeClr val="lt1"/>
-          </a:fontRef>
-        </p:style>
-        <p:txBody>
-          <a:bodyPr rtlCol="0" anchor="ctr" wrap="square" lIns="36576" tIns="29260" rIns="36576" bIns="29260">
+            <a:srgbClr val="E3F2F1"/>
+          </a:solidFill>
+          <a:ln w="12700">
+            <a:solidFill>
+              <a:srgbClr val="0E7C7B"/>
+            </a:solidFill>
+          </a:ln>
+          <a:effectLst/>
+        </p:spPr>
+        <p:style>
+          <a:lnRef idx="1">
+            <a:schemeClr val="accent1"/>
+          </a:lnRef>
+          <a:fillRef idx="3">
+            <a:schemeClr val="accent1"/>
+          </a:fillRef>
+          <a:effectRef idx="2">
+            <a:schemeClr val="accent1"/>
+          </a:effectRef>
+          <a:fontRef idx="minor">
+            <a:schemeClr val="lt1"/>
+          </a:fontRef>
+        </p:style>
+        <p:txBody>
+          <a:bodyPr rtlCol="0" anchor="ctr" wrap="square" lIns="27432" tIns="21945" rIns="27432" bIns="21945">
             <a:noAutofit/>
           </a:bodyPr>
           <a:lstStyle/>
@@ -13437,73 +12141,29 @@
               </a:spcAft>
             </a:pPr>
             <a:r>
-              <a:rPr sz="1300" b="1" i="0" lang="en-GB">
-                <a:solidFill>
-                  <a:srgbClr val="FFFFFF"/>
-                </a:solidFill>
-                <a:latin typeface="Aptos"/>
-                <a:ea typeface="Aptos"/>
-                <a:cs typeface="Dubai"/>
-              </a:rPr>
-              <a:t>Phase 1</a:t>
-            </a:r>
-          </a:p>
-        </p:txBody>
-      </p:sp>
-      <p:sp>
-        <p:nvSpPr>
-          <p:cNvPr id="14" name="Chevron 13"/>
-          <p:cNvSpPr/>
-          <p:nvPr/>
-        </p:nvSpPr>
-        <p:spPr>
-          <a:xfrm>
-            <a:off x="6030468" y="1947672"/>
-            <a:ext cx="128016" cy="237744"/>
-          </a:xfrm>
-          <a:prstGeom prst="chevron">
-            <a:avLst/>
-          </a:prstGeom>
-          <a:solidFill>
-            <a:srgbClr val="D5DBE1"/>
-          </a:solidFill>
-          <a:ln>
-            <a:noFill/>
-          </a:ln>
-          <a:effectLst/>
-        </p:spPr>
-        <p:style>
-          <a:lnRef idx="1">
-            <a:schemeClr val="accent1"/>
-          </a:lnRef>
-          <a:fillRef idx="3">
-            <a:schemeClr val="accent1"/>
-          </a:fillRef>
-          <a:effectRef idx="2">
-            <a:schemeClr val="accent1"/>
-          </a:effectRef>
-          <a:fontRef idx="minor">
-            <a:schemeClr val="lt1"/>
-          </a:fontRef>
-        </p:style>
-        <p:txBody>
-          <a:bodyPr rtlCol="0" anchor="ctr"/>
-          <a:lstStyle/>
-          <a:p>
-            <a:pPr algn="ctr"/>
-          </a:p>
-        </p:txBody>
-      </p:sp>
-      <p:sp>
-        <p:nvSpPr>
-          <p:cNvPr id="15" name="TextBox 14"/>
+              <a:rPr sz="950" b="1" i="0" lang="en-GB">
+                <a:solidFill>
+                  <a:srgbClr val="0E7C7B"/>
+                </a:solidFill>
+                <a:latin typeface="Aptos"/>
+                <a:ea typeface="Aptos"/>
+                <a:cs typeface="Dubai"/>
+              </a:rPr>
+              <a:t>MET</a:t>
+            </a:r>
+          </a:p>
+        </p:txBody>
+      </p:sp>
+      <p:sp>
+        <p:nvSpPr>
+          <p:cNvPr id="19" name="TextBox 18"/>
           <p:cNvSpPr txBox="1"/>
           <p:nvPr/>
         </p:nvSpPr>
         <p:spPr>
           <a:xfrm>
-            <a:off x="3367278" y="2514600"/>
-            <a:ext cx="2635758" cy="365760"/>
+            <a:off x="4585716" y="2304288"/>
+            <a:ext cx="3108960" cy="438912"/>
           </a:xfrm>
           <a:prstGeom prst="rect">
             <a:avLst/>
@@ -13517,6 +12177,9 @@
           <a:lstStyle/>
           <a:p>
             <a:pPr algn="l">
+              <a:lnSpc>
+                <a:spcPct val="95000"/>
+              </a:lnSpc>
               <a:spcBef>
                 <a:spcPts val="0"/>
               </a:spcBef>
@@ -13525,29 +12188,29 @@
               </a:spcAft>
             </a:pPr>
             <a:r>
-              <a:rPr sz="1800" b="1" i="0" lang="en-GB">
-                <a:solidFill>
-                  <a:srgbClr val="0F2A44"/>
-                </a:solidFill>
-                <a:latin typeface="Aptos"/>
-                <a:ea typeface="Aptos"/>
-                <a:cs typeface="Dubai"/>
-              </a:rPr>
-              <a:t>Baseline</a:t>
-            </a:r>
-          </a:p>
-        </p:txBody>
-      </p:sp>
-      <p:sp>
-        <p:nvSpPr>
-          <p:cNvPr id="16" name="TextBox 15"/>
+              <a:rPr sz="1200" b="0" i="0" lang="en-GB">
+                <a:solidFill>
+                  <a:srgbClr val="5B6573"/>
+                </a:solidFill>
+                <a:latin typeface="Aptos"/>
+                <a:ea typeface="Aptos"/>
+                <a:cs typeface="Dubai"/>
+              </a:rPr>
+              <a:t>the largest gap allowed between dialect and formal Arabic</a:t>
+            </a:r>
+          </a:p>
+        </p:txBody>
+      </p:sp>
+      <p:sp>
+        <p:nvSpPr>
+          <p:cNvPr id="20" name="TextBox 19"/>
           <p:cNvSpPr txBox="1"/>
           <p:nvPr/>
         </p:nvSpPr>
         <p:spPr>
           <a:xfrm>
-            <a:off x="3367278" y="2880360"/>
-            <a:ext cx="2635758" cy="868680"/>
+            <a:off x="4585716" y="2743200"/>
+            <a:ext cx="3108960" cy="640080"/>
           </a:xfrm>
           <a:prstGeom prst="rect">
             <a:avLst/>
@@ -13561,6 +12224,9 @@
           <a:lstStyle/>
           <a:p>
             <a:pPr algn="l">
+              <a:lnSpc>
+                <a:spcPct val="95000"/>
+              </a:lnSpc>
               <a:spcBef>
                 <a:spcPts val="0"/>
               </a:spcBef>
@@ -13569,7 +12235,18 @@
               </a:spcAft>
             </a:pPr>
             <a:r>
-              <a:rPr sz="1350" b="0" i="0" lang="en-GB">
+              <a:rPr sz="1250" b="1" i="0" lang="en-GB">
+                <a:solidFill>
+                  <a:srgbClr val="0E7C7B"/>
+                </a:solidFill>
+                <a:latin typeface="Aptos"/>
+                <a:ea typeface="Aptos"/>
+                <a:cs typeface="Dubai"/>
+              </a:rPr>
+              <a:t>Measured: </a:t>
+            </a:r>
+            <a:r>
+              <a:rPr sz="1250" b="0" i="0" lang="en-GB">
                 <a:solidFill>
                   <a:srgbClr val="1F2937"/>
                 </a:solidFill>
@@ -13577,29 +12254,29 @@
                 <a:ea typeface="Aptos"/>
                 <a:cs typeface="Dubai"/>
               </a:rPr>
-              <a:t>Upload, detect, track, index. First Arabic search and test set.</a:t>
-            </a:r>
-          </a:p>
-        </p:txBody>
-      </p:sp>
-      <p:sp>
-        <p:nvSpPr>
-          <p:cNvPr id="17" name="Rounded Rectangle 16"/>
-          <p:cNvSpPr/>
-          <p:nvPr/>
-        </p:nvSpPr>
-        <p:spPr>
-          <a:xfrm>
-            <a:off x="6185916" y="1783080"/>
-            <a:ext cx="2635758" cy="566928"/>
+              <a:t>no gap with phase 2: Jordanian, Gulf and formal all 100%. Option A: 17 points.</a:t>
+            </a:r>
+          </a:p>
+        </p:txBody>
+      </p:sp>
+      <p:sp>
+        <p:nvSpPr>
+          <p:cNvPr id="21" name="Rounded Rectangle 20"/>
+          <p:cNvSpPr/>
+          <p:nvPr/>
+        </p:nvSpPr>
+        <p:spPr>
+          <a:xfrm>
+            <a:off x="8074152" y="1737360"/>
+            <a:ext cx="3566160" cy="1719072"/>
           </a:xfrm>
           <a:prstGeom prst="roundRect">
             <a:avLst>
-              <a:gd name="adj" fmla="val 12000"/>
+              <a:gd name="adj" fmla="val 6000"/>
             </a:avLst>
           </a:prstGeom>
           <a:solidFill>
-            <a:srgbClr val="0E7C7B"/>
+            <a:srgbClr val="F3F5F7"/>
           </a:solidFill>
           <a:ln>
             <a:noFill/>
@@ -13621,49 +12298,29 @@
           </a:fontRef>
         </p:style>
         <p:txBody>
-          <a:bodyPr rtlCol="0" anchor="ctr" wrap="square" lIns="36576" tIns="29260" rIns="36576" bIns="29260">
-            <a:noAutofit/>
-          </a:bodyPr>
-          <a:lstStyle/>
-          <a:p>
-            <a:pPr algn="ctr">
-              <a:spcBef>
-                <a:spcPts val="0"/>
-              </a:spcBef>
-              <a:spcAft>
-                <a:spcPts val="0"/>
-              </a:spcAft>
-            </a:pPr>
-            <a:r>
-              <a:rPr sz="1300" b="1" i="0" lang="en-GB">
-                <a:solidFill>
-                  <a:srgbClr val="FFFFFF"/>
-                </a:solidFill>
-                <a:latin typeface="Aptos"/>
-                <a:ea typeface="Aptos"/>
-                <a:cs typeface="Dubai"/>
-              </a:rPr>
-              <a:t>Phase 2</a:t>
-            </a:r>
-          </a:p>
-        </p:txBody>
-      </p:sp>
-      <p:sp>
-        <p:nvSpPr>
-          <p:cNvPr id="18" name="Chevron 17"/>
-          <p:cNvSpPr/>
-          <p:nvPr/>
-        </p:nvSpPr>
-        <p:spPr>
-          <a:xfrm>
-            <a:off x="8849106" y="1947672"/>
-            <a:ext cx="128016" cy="237744"/>
-          </a:xfrm>
-          <a:prstGeom prst="chevron">
-            <a:avLst/>
-          </a:prstGeom>
-          <a:solidFill>
-            <a:srgbClr val="D5DBE1"/>
+          <a:bodyPr rtlCol="0" anchor="ctr"/>
+          <a:lstStyle/>
+          <a:p>
+            <a:pPr algn="ctr"/>
+          </a:p>
+        </p:txBody>
+      </p:sp>
+      <p:sp>
+        <p:nvSpPr>
+          <p:cNvPr id="22" name="Rectangle 21"/>
+          <p:cNvSpPr/>
+          <p:nvPr/>
+        </p:nvSpPr>
+        <p:spPr>
+          <a:xfrm>
+            <a:off x="8074152" y="1920240"/>
+            <a:ext cx="64008" cy="1353312"/>
+          </a:xfrm>
+          <a:prstGeom prst="rect">
+            <a:avLst/>
+          </a:prstGeom>
+          <a:solidFill>
+            <a:srgbClr val="B45F06"/>
           </a:solidFill>
           <a:ln>
             <a:noFill/>
@@ -13694,14 +12351,14 @@
       </p:sp>
       <p:sp>
         <p:nvSpPr>
-          <p:cNvPr id="19" name="TextBox 18"/>
+          <p:cNvPr id="23" name="TextBox 22"/>
           <p:cNvSpPr txBox="1"/>
           <p:nvPr/>
         </p:nvSpPr>
         <p:spPr>
           <a:xfrm>
-            <a:off x="6185916" y="2514600"/>
-            <a:ext cx="2635758" cy="365760"/>
+            <a:off x="8348472" y="1865376"/>
+            <a:ext cx="2011680" cy="457200"/>
           </a:xfrm>
           <a:prstGeom prst="rect">
             <a:avLst/>
@@ -13723,7 +12380,7 @@
               </a:spcAft>
             </a:pPr>
             <a:r>
-              <a:rPr sz="1800" b="1" i="0" lang="en-GB">
+              <a:rPr sz="2600" b="1" i="0" lang="en-GB">
                 <a:solidFill>
                   <a:srgbClr val="0F2A44"/>
                 </a:solidFill>
@@ -13731,21 +12388,89 @@
                 <a:ea typeface="Aptos"/>
                 <a:cs typeface="Dubai"/>
               </a:rPr>
-              <a:t>Arabic hybrid</a:t>
-            </a:r>
-          </a:p>
-        </p:txBody>
-      </p:sp>
-      <p:sp>
-        <p:nvSpPr>
-          <p:cNvPr id="20" name="TextBox 19"/>
+              <a:t>3 of 5</a:t>
+            </a:r>
+          </a:p>
+        </p:txBody>
+      </p:sp>
+      <p:sp>
+        <p:nvSpPr>
+          <p:cNvPr id="24" name="Rounded Rectangle 23"/>
+          <p:cNvSpPr/>
+          <p:nvPr/>
+        </p:nvSpPr>
+        <p:spPr>
+          <a:xfrm>
+            <a:off x="10588752" y="1920240"/>
+            <a:ext cx="868680" cy="274320"/>
+          </a:xfrm>
+          <a:prstGeom prst="roundRect">
+            <a:avLst>
+              <a:gd name="adj" fmla="val 50000"/>
+            </a:avLst>
+          </a:prstGeom>
+          <a:solidFill>
+            <a:srgbClr val="FDF1E1"/>
+          </a:solidFill>
+          <a:ln w="12700">
+            <a:solidFill>
+              <a:srgbClr val="B45F06"/>
+            </a:solidFill>
+          </a:ln>
+          <a:effectLst/>
+        </p:spPr>
+        <p:style>
+          <a:lnRef idx="1">
+            <a:schemeClr val="accent1"/>
+          </a:lnRef>
+          <a:fillRef idx="3">
+            <a:schemeClr val="accent1"/>
+          </a:fillRef>
+          <a:effectRef idx="2">
+            <a:schemeClr val="accent1"/>
+          </a:effectRef>
+          <a:fontRef idx="minor">
+            <a:schemeClr val="lt1"/>
+          </a:fontRef>
+        </p:style>
+        <p:txBody>
+          <a:bodyPr rtlCol="0" anchor="ctr" wrap="square" lIns="27432" tIns="21945" rIns="27432" bIns="21945">
+            <a:noAutofit/>
+          </a:bodyPr>
+          <a:lstStyle/>
+          <a:p>
+            <a:pPr algn="ctr">
+              <a:spcBef>
+                <a:spcPts val="0"/>
+              </a:spcBef>
+              <a:spcAft>
+                <a:spcPts val="0"/>
+              </a:spcAft>
+            </a:pPr>
+            <a:r>
+              <a:rPr sz="950" b="1" i="0" lang="en-GB">
+                <a:solidFill>
+                  <a:srgbClr val="B45F06"/>
+                </a:solidFill>
+                <a:latin typeface="Aptos"/>
+                <a:ea typeface="Aptos"/>
+                <a:cs typeface="Dubai"/>
+              </a:rPr>
+              <a:t>MISSED</a:t>
+            </a:r>
+          </a:p>
+        </p:txBody>
+      </p:sp>
+      <p:sp>
+        <p:nvSpPr>
+          <p:cNvPr id="25" name="TextBox 24"/>
           <p:cNvSpPr txBox="1"/>
           <p:nvPr/>
         </p:nvSpPr>
         <p:spPr>
           <a:xfrm>
-            <a:off x="6185916" y="2880360"/>
-            <a:ext cx="2635758" cy="868680"/>
+            <a:off x="8348472" y="2304288"/>
+            <a:ext cx="3108960" cy="438912"/>
           </a:xfrm>
           <a:prstGeom prst="rect">
             <a:avLst/>
@@ -13759,6 +12484,9 @@
           <a:lstStyle/>
           <a:p>
             <a:pPr algn="l">
+              <a:lnSpc>
+                <a:spcPct val="95000"/>
+              </a:lnSpc>
               <a:spcBef>
                 <a:spcPts val="0"/>
               </a:spcBef>
@@ -13767,95 +12495,29 @@
               </a:spcAft>
             </a:pPr>
             <a:r>
-              <a:rPr sz="1350" b="0" i="0" lang="en-GB">
-                <a:solidFill>
-                  <a:srgbClr val="1F2937"/>
-                </a:solidFill>
-                <a:latin typeface="Aptos"/>
-                <a:ea typeface="Aptos"/>
-                <a:cs typeface="Dubai"/>
-              </a:rPr>
-              <a:t>Dialect-aware query reading, clothing details, double-check step.</a:t>
-            </a:r>
-          </a:p>
-        </p:txBody>
-      </p:sp>
-      <p:sp>
-        <p:nvSpPr>
-          <p:cNvPr id="21" name="Rounded Rectangle 20"/>
-          <p:cNvSpPr/>
-          <p:nvPr/>
-        </p:nvSpPr>
-        <p:spPr>
-          <a:xfrm>
-            <a:off x="9004554" y="1783080"/>
-            <a:ext cx="2635758" cy="566928"/>
-          </a:xfrm>
-          <a:prstGeom prst="roundRect">
-            <a:avLst>
-              <a:gd name="adj" fmla="val 12000"/>
-            </a:avLst>
-          </a:prstGeom>
-          <a:solidFill>
-            <a:srgbClr val="0F2A44"/>
-          </a:solidFill>
-          <a:ln>
-            <a:noFill/>
-          </a:ln>
-          <a:effectLst/>
-        </p:spPr>
-        <p:style>
-          <a:lnRef idx="1">
-            <a:schemeClr val="accent1"/>
-          </a:lnRef>
-          <a:fillRef idx="3">
-            <a:schemeClr val="accent1"/>
-          </a:fillRef>
-          <a:effectRef idx="2">
-            <a:schemeClr val="accent1"/>
-          </a:effectRef>
-          <a:fontRef idx="minor">
-            <a:schemeClr val="lt1"/>
-          </a:fontRef>
-        </p:style>
-        <p:txBody>
-          <a:bodyPr rtlCol="0" anchor="ctr" wrap="square" lIns="36576" tIns="29260" rIns="36576" bIns="29260">
-            <a:noAutofit/>
-          </a:bodyPr>
-          <a:lstStyle/>
-          <a:p>
-            <a:pPr algn="ctr">
-              <a:spcBef>
-                <a:spcPts val="0"/>
-              </a:spcBef>
-              <a:spcAft>
-                <a:spcPts val="0"/>
-              </a:spcAft>
-            </a:pPr>
-            <a:r>
-              <a:rPr sz="1300" b="1" i="0" lang="en-GB">
-                <a:solidFill>
-                  <a:srgbClr val="FFFFFF"/>
-                </a:solidFill>
-                <a:latin typeface="Aptos"/>
-                <a:ea typeface="Aptos"/>
-                <a:cs typeface="Dubai"/>
-              </a:rPr>
-              <a:t>Phase 3</a:t>
-            </a:r>
-          </a:p>
-        </p:txBody>
-      </p:sp>
-      <p:sp>
-        <p:nvSpPr>
-          <p:cNvPr id="22" name="TextBox 21"/>
+              <a:rPr sz="1200" b="0" i="0" lang="en-GB">
+                <a:solidFill>
+                  <a:srgbClr val="5B6573"/>
+                </a:solidFill>
+                <a:latin typeface="Aptos"/>
+                <a:ea typeface="Aptos"/>
+                <a:cs typeface="Dubai"/>
+              </a:rPr>
+              <a:t>top results correct, on average</a:t>
+            </a:r>
+          </a:p>
+        </p:txBody>
+      </p:sp>
+      <p:sp>
+        <p:nvSpPr>
+          <p:cNvPr id="26" name="TextBox 25"/>
           <p:cNvSpPr txBox="1"/>
           <p:nvPr/>
         </p:nvSpPr>
         <p:spPr>
           <a:xfrm>
-            <a:off x="9004554" y="2514600"/>
-            <a:ext cx="2635758" cy="365760"/>
+            <a:off x="8348472" y="2743200"/>
+            <a:ext cx="3108960" cy="640080"/>
           </a:xfrm>
           <a:prstGeom prst="rect">
             <a:avLst/>
@@ -13869,6 +12531,9 @@
           <a:lstStyle/>
           <a:p>
             <a:pPr algn="l">
+              <a:lnSpc>
+                <a:spcPct val="95000"/>
+              </a:lnSpc>
               <a:spcBef>
                 <a:spcPts val="0"/>
               </a:spcBef>
@@ -13877,29 +12542,130 @@
               </a:spcAft>
             </a:pPr>
             <a:r>
-              <a:rPr sz="1800" b="1" i="0" lang="en-GB">
-                <a:solidFill>
-                  <a:srgbClr val="0F2A44"/>
-                </a:solidFill>
-                <a:latin typeface="Aptos"/>
-                <a:ea typeface="Aptos"/>
-                <a:cs typeface="Dubai"/>
-              </a:rPr>
-              <a:t>Demo-ready</a:t>
-            </a:r>
-          </a:p>
-        </p:txBody>
-      </p:sp>
-      <p:sp>
-        <p:nvSpPr>
-          <p:cNvPr id="23" name="TextBox 22"/>
+              <a:rPr sz="1250" b="1" i="0" lang="en-GB">
+                <a:solidFill>
+                  <a:srgbClr val="B45F06"/>
+                </a:solidFill>
+                <a:latin typeface="Aptos"/>
+                <a:ea typeface="Aptos"/>
+                <a:cs typeface="Dubai"/>
+              </a:rPr>
+              <a:t>Measured: </a:t>
+            </a:r>
+            <a:r>
+              <a:rPr sz="1250" b="0" i="0" lang="en-GB">
+                <a:solidFill>
+                  <a:srgbClr val="1F2937"/>
+                </a:solidFill>
+                <a:latin typeface="Aptos"/>
+                <a:ea typeface="Aptos"/>
+                <a:cs typeface="Dubai"/>
+              </a:rPr>
+              <a:t>about 2.5 of 5 (0.49 after the double-check). Capped where fewer than 5 are correct.</a:t>
+            </a:r>
+          </a:p>
+        </p:txBody>
+      </p:sp>
+      <p:sp>
+        <p:nvSpPr>
+          <p:cNvPr id="27" name="Rounded Rectangle 26"/>
+          <p:cNvSpPr/>
+          <p:nvPr/>
+        </p:nvSpPr>
+        <p:spPr>
+          <a:xfrm>
+            <a:off x="548640" y="3602736"/>
+            <a:ext cx="3566160" cy="1719072"/>
+          </a:xfrm>
+          <a:prstGeom prst="roundRect">
+            <a:avLst>
+              <a:gd name="adj" fmla="val 6000"/>
+            </a:avLst>
+          </a:prstGeom>
+          <a:solidFill>
+            <a:srgbClr val="F3F5F7"/>
+          </a:solidFill>
+          <a:ln>
+            <a:noFill/>
+          </a:ln>
+          <a:effectLst/>
+        </p:spPr>
+        <p:style>
+          <a:lnRef idx="1">
+            <a:schemeClr val="accent1"/>
+          </a:lnRef>
+          <a:fillRef idx="3">
+            <a:schemeClr val="accent1"/>
+          </a:fillRef>
+          <a:effectRef idx="2">
+            <a:schemeClr val="accent1"/>
+          </a:effectRef>
+          <a:fontRef idx="minor">
+            <a:schemeClr val="lt1"/>
+          </a:fontRef>
+        </p:style>
+        <p:txBody>
+          <a:bodyPr rtlCol="0" anchor="ctr"/>
+          <a:lstStyle/>
+          <a:p>
+            <a:pPr algn="ctr"/>
+          </a:p>
+        </p:txBody>
+      </p:sp>
+      <p:sp>
+        <p:nvSpPr>
+          <p:cNvPr id="28" name="Rectangle 27"/>
+          <p:cNvSpPr/>
+          <p:nvPr/>
+        </p:nvSpPr>
+        <p:spPr>
+          <a:xfrm>
+            <a:off x="548640" y="3785615"/>
+            <a:ext cx="64008" cy="1353312"/>
+          </a:xfrm>
+          <a:prstGeom prst="rect">
+            <a:avLst/>
+          </a:prstGeom>
+          <a:solidFill>
+            <a:srgbClr val="B45F06"/>
+          </a:solidFill>
+          <a:ln>
+            <a:noFill/>
+          </a:ln>
+          <a:effectLst/>
+        </p:spPr>
+        <p:style>
+          <a:lnRef idx="1">
+            <a:schemeClr val="accent1"/>
+          </a:lnRef>
+          <a:fillRef idx="3">
+            <a:schemeClr val="accent1"/>
+          </a:fillRef>
+          <a:effectRef idx="2">
+            <a:schemeClr val="accent1"/>
+          </a:effectRef>
+          <a:fontRef idx="minor">
+            <a:schemeClr val="lt1"/>
+          </a:fontRef>
+        </p:style>
+        <p:txBody>
+          <a:bodyPr rtlCol="0" anchor="ctr"/>
+          <a:lstStyle/>
+          <a:p>
+            <a:pPr algn="ctr"/>
+          </a:p>
+        </p:txBody>
+      </p:sp>
+      <p:sp>
+        <p:nvSpPr>
+          <p:cNvPr id="29" name="TextBox 28"/>
           <p:cNvSpPr txBox="1"/>
           <p:nvPr/>
         </p:nvSpPr>
         <p:spPr>
           <a:xfrm>
-            <a:off x="9004554" y="2880360"/>
-            <a:ext cx="2635758" cy="868680"/>
+            <a:off x="822959" y="3730752"/>
+            <a:ext cx="2011680" cy="457200"/>
           </a:xfrm>
           <a:prstGeom prst="rect">
             <a:avLst/>
@@ -13921,29 +12687,97 @@
               </a:spcAft>
             </a:pPr>
             <a:r>
-              <a:rPr sz="1350" b="0" i="0" lang="en-GB">
-                <a:solidFill>
-                  <a:srgbClr val="1F2937"/>
-                </a:solidFill>
-                <a:latin typeface="Aptos"/>
-                <a:ea typeface="Aptos"/>
-                <a:cs typeface="Dubai"/>
-              </a:rPr>
-              <a:t>Timeline across cameras, audit log, demo script, results write-up.</a:t>
-            </a:r>
-          </a:p>
-        </p:txBody>
-      </p:sp>
-      <p:sp>
-        <p:nvSpPr>
-          <p:cNvPr id="24" name="TextBox 23"/>
+              <a:rPr sz="2600" b="1" i="0" lang="en-GB">
+                <a:solidFill>
+                  <a:srgbClr val="0F2A44"/>
+                </a:solidFill>
+                <a:latin typeface="Aptos"/>
+                <a:ea typeface="Aptos"/>
+                <a:cs typeface="Dubai"/>
+              </a:rPr>
+              <a:t>&lt; 20 min</a:t>
+            </a:r>
+          </a:p>
+        </p:txBody>
+      </p:sp>
+      <p:sp>
+        <p:nvSpPr>
+          <p:cNvPr id="30" name="Rounded Rectangle 29"/>
+          <p:cNvSpPr/>
+          <p:nvPr/>
+        </p:nvSpPr>
+        <p:spPr>
+          <a:xfrm>
+            <a:off x="3063239" y="3785615"/>
+            <a:ext cx="868680" cy="274320"/>
+          </a:xfrm>
+          <a:prstGeom prst="roundRect">
+            <a:avLst>
+              <a:gd name="adj" fmla="val 50000"/>
+            </a:avLst>
+          </a:prstGeom>
+          <a:solidFill>
+            <a:srgbClr val="FDF1E1"/>
+          </a:solidFill>
+          <a:ln w="12700">
+            <a:solidFill>
+              <a:srgbClr val="B45F06"/>
+            </a:solidFill>
+          </a:ln>
+          <a:effectLst/>
+        </p:spPr>
+        <p:style>
+          <a:lnRef idx="1">
+            <a:schemeClr val="accent1"/>
+          </a:lnRef>
+          <a:fillRef idx="3">
+            <a:schemeClr val="accent1"/>
+          </a:fillRef>
+          <a:effectRef idx="2">
+            <a:schemeClr val="accent1"/>
+          </a:effectRef>
+          <a:fontRef idx="minor">
+            <a:schemeClr val="lt1"/>
+          </a:fontRef>
+        </p:style>
+        <p:txBody>
+          <a:bodyPr rtlCol="0" anchor="ctr" wrap="square" lIns="27432" tIns="21945" rIns="27432" bIns="21945">
+            <a:noAutofit/>
+          </a:bodyPr>
+          <a:lstStyle/>
+          <a:p>
+            <a:pPr algn="ctr">
+              <a:spcBef>
+                <a:spcPts val="0"/>
+              </a:spcBef>
+              <a:spcAft>
+                <a:spcPts val="0"/>
+              </a:spcAft>
+            </a:pPr>
+            <a:r>
+              <a:rPr sz="950" b="1" i="0" lang="en-GB">
+                <a:solidFill>
+                  <a:srgbClr val="B45F06"/>
+                </a:solidFill>
+                <a:latin typeface="Aptos"/>
+                <a:ea typeface="Aptos"/>
+                <a:cs typeface="Dubai"/>
+              </a:rPr>
+              <a:t>MISSED</a:t>
+            </a:r>
+          </a:p>
+        </p:txBody>
+      </p:sp>
+      <p:sp>
+        <p:nvSpPr>
+          <p:cNvPr id="31" name="TextBox 30"/>
           <p:cNvSpPr txBox="1"/>
           <p:nvPr/>
         </p:nvSpPr>
         <p:spPr>
           <a:xfrm>
-            <a:off x="548640" y="3931920"/>
-            <a:ext cx="5486400" cy="292608"/>
+            <a:off x="822959" y="4169663"/>
+            <a:ext cx="3108960" cy="438912"/>
           </a:xfrm>
           <a:prstGeom prst="rect">
             <a:avLst/>
@@ -13957,6 +12791,9 @@
           <a:lstStyle/>
           <a:p>
             <a:pPr algn="l">
+              <a:lnSpc>
+                <a:spcPct val="95000"/>
+              </a:lnSpc>
               <a:spcBef>
                 <a:spcPts val="0"/>
               </a:spcBef>
@@ -13965,7 +12802,7 @@
               </a:spcAft>
             </a:pPr>
             <a:r>
-              <a:rPr sz="1100" b="1" i="0" lang="en-GB">
+              <a:rPr sz="1200" b="0" i="0" lang="en-GB">
                 <a:solidFill>
                   <a:srgbClr val="5B6573"/>
                 </a:solidFill>
@@ -13973,21 +12810,693 @@
                 <a:ea typeface="Aptos"/>
                 <a:cs typeface="Dubai"/>
               </a:rPr>
-              <a:t>AFTER THE POC</a:t>
-            </a:r>
-          </a:p>
-        </p:txBody>
-      </p:sp>
-      <p:sp>
-        <p:nvSpPr>
-          <p:cNvPr id="25" name="Rounded Rectangle 24"/>
-          <p:cNvSpPr/>
-          <p:nvPr/>
-        </p:nvSpPr>
-        <p:spPr>
-          <a:xfrm>
-            <a:off x="548640" y="4251960"/>
-            <a:ext cx="2606040" cy="960120"/>
+              <a:t>to index the demo clips</a:t>
+            </a:r>
+          </a:p>
+        </p:txBody>
+      </p:sp>
+      <p:sp>
+        <p:nvSpPr>
+          <p:cNvPr id="32" name="TextBox 31"/>
+          <p:cNvSpPr txBox="1"/>
+          <p:nvPr/>
+        </p:nvSpPr>
+        <p:spPr>
+          <a:xfrm>
+            <a:off x="822959" y="4608576"/>
+            <a:ext cx="3108960" cy="640080"/>
+          </a:xfrm>
+          <a:prstGeom prst="rect">
+            <a:avLst/>
+          </a:prstGeom>
+          <a:noFill/>
+        </p:spPr>
+        <p:txBody>
+          <a:bodyPr wrap="square" lIns="0" tIns="0" rIns="0" bIns="0" anchor="t">
+            <a:noAutofit/>
+          </a:bodyPr>
+          <a:lstStyle/>
+          <a:p>
+            <a:pPr algn="l">
+              <a:lnSpc>
+                <a:spcPct val="95000"/>
+              </a:lnSpc>
+              <a:spcBef>
+                <a:spcPts val="0"/>
+              </a:spcBef>
+              <a:spcAft>
+                <a:spcPts val="0"/>
+              </a:spcAft>
+            </a:pPr>
+            <a:r>
+              <a:rPr sz="1250" b="1" i="0" lang="en-GB">
+                <a:solidFill>
+                  <a:srgbClr val="B45F06"/>
+                </a:solidFill>
+                <a:latin typeface="Aptos"/>
+                <a:ea typeface="Aptos"/>
+                <a:cs typeface="Dubai"/>
+              </a:rPr>
+              <a:t>Measured: </a:t>
+            </a:r>
+            <a:r>
+              <a:rPr sz="1250" b="0" i="0" lang="en-GB">
+                <a:solidFill>
+                  <a:srgbClr val="1F2937"/>
+                </a:solidFill>
+                <a:latin typeface="Aptos"/>
+                <a:ea typeface="Aptos"/>
+                <a:cs typeface="Dubai"/>
+              </a:rPr>
+              <a:t>44 min for the 11 starter clips, 36.5 of them for clothing details; about 7 without.</a:t>
+            </a:r>
+          </a:p>
+        </p:txBody>
+      </p:sp>
+      <p:sp>
+        <p:nvSpPr>
+          <p:cNvPr id="33" name="Rounded Rectangle 32"/>
+          <p:cNvSpPr/>
+          <p:nvPr/>
+        </p:nvSpPr>
+        <p:spPr>
+          <a:xfrm>
+            <a:off x="4311396" y="3602736"/>
+            <a:ext cx="3566160" cy="1719072"/>
+          </a:xfrm>
+          <a:prstGeom prst="roundRect">
+            <a:avLst>
+              <a:gd name="adj" fmla="val 6000"/>
+            </a:avLst>
+          </a:prstGeom>
+          <a:solidFill>
+            <a:srgbClr val="F3F5F7"/>
+          </a:solidFill>
+          <a:ln>
+            <a:noFill/>
+          </a:ln>
+          <a:effectLst/>
+        </p:spPr>
+        <p:style>
+          <a:lnRef idx="1">
+            <a:schemeClr val="accent1"/>
+          </a:lnRef>
+          <a:fillRef idx="3">
+            <a:schemeClr val="accent1"/>
+          </a:fillRef>
+          <a:effectRef idx="2">
+            <a:schemeClr val="accent1"/>
+          </a:effectRef>
+          <a:fontRef idx="minor">
+            <a:schemeClr val="lt1"/>
+          </a:fontRef>
+        </p:style>
+        <p:txBody>
+          <a:bodyPr rtlCol="0" anchor="ctr"/>
+          <a:lstStyle/>
+          <a:p>
+            <a:pPr algn="ctr"/>
+          </a:p>
+        </p:txBody>
+      </p:sp>
+      <p:sp>
+        <p:nvSpPr>
+          <p:cNvPr id="34" name="Rectangle 33"/>
+          <p:cNvSpPr/>
+          <p:nvPr/>
+        </p:nvSpPr>
+        <p:spPr>
+          <a:xfrm>
+            <a:off x="4311396" y="3785615"/>
+            <a:ext cx="64008" cy="1353312"/>
+          </a:xfrm>
+          <a:prstGeom prst="rect">
+            <a:avLst/>
+          </a:prstGeom>
+          <a:solidFill>
+            <a:srgbClr val="0E7C7B"/>
+          </a:solidFill>
+          <a:ln>
+            <a:noFill/>
+          </a:ln>
+          <a:effectLst/>
+        </p:spPr>
+        <p:style>
+          <a:lnRef idx="1">
+            <a:schemeClr val="accent1"/>
+          </a:lnRef>
+          <a:fillRef idx="3">
+            <a:schemeClr val="accent1"/>
+          </a:fillRef>
+          <a:effectRef idx="2">
+            <a:schemeClr val="accent1"/>
+          </a:effectRef>
+          <a:fontRef idx="minor">
+            <a:schemeClr val="lt1"/>
+          </a:fontRef>
+        </p:style>
+        <p:txBody>
+          <a:bodyPr rtlCol="0" anchor="ctr"/>
+          <a:lstStyle/>
+          <a:p>
+            <a:pPr algn="ctr"/>
+          </a:p>
+        </p:txBody>
+      </p:sp>
+      <p:sp>
+        <p:nvSpPr>
+          <p:cNvPr id="35" name="TextBox 34"/>
+          <p:cNvSpPr txBox="1"/>
+          <p:nvPr/>
+        </p:nvSpPr>
+        <p:spPr>
+          <a:xfrm>
+            <a:off x="4585716" y="3730752"/>
+            <a:ext cx="2011680" cy="457200"/>
+          </a:xfrm>
+          <a:prstGeom prst="rect">
+            <a:avLst/>
+          </a:prstGeom>
+          <a:noFill/>
+        </p:spPr>
+        <p:txBody>
+          <a:bodyPr wrap="square" lIns="0" tIns="0" rIns="0" bIns="0" anchor="t">
+            <a:noAutofit/>
+          </a:bodyPr>
+          <a:lstStyle/>
+          <a:p>
+            <a:pPr algn="l">
+              <a:spcBef>
+                <a:spcPts val="0"/>
+              </a:spcBef>
+              <a:spcAft>
+                <a:spcPts val="0"/>
+              </a:spcAft>
+            </a:pPr>
+            <a:r>
+              <a:rPr sz="2600" b="1" i="0" lang="en-GB">
+                <a:solidFill>
+                  <a:srgbClr val="0F2A44"/>
+                </a:solidFill>
+                <a:latin typeface="Aptos"/>
+                <a:ea typeface="Aptos"/>
+                <a:cs typeface="Dubai"/>
+              </a:rPr>
+              <a:t>&lt; 5 s</a:t>
+            </a:r>
+          </a:p>
+        </p:txBody>
+      </p:sp>
+      <p:sp>
+        <p:nvSpPr>
+          <p:cNvPr id="36" name="Rounded Rectangle 35"/>
+          <p:cNvSpPr/>
+          <p:nvPr/>
+        </p:nvSpPr>
+        <p:spPr>
+          <a:xfrm>
+            <a:off x="6825996" y="3785615"/>
+            <a:ext cx="868680" cy="274320"/>
+          </a:xfrm>
+          <a:prstGeom prst="roundRect">
+            <a:avLst>
+              <a:gd name="adj" fmla="val 50000"/>
+            </a:avLst>
+          </a:prstGeom>
+          <a:solidFill>
+            <a:srgbClr val="E3F2F1"/>
+          </a:solidFill>
+          <a:ln w="12700">
+            <a:solidFill>
+              <a:srgbClr val="0E7C7B"/>
+            </a:solidFill>
+          </a:ln>
+          <a:effectLst/>
+        </p:spPr>
+        <p:style>
+          <a:lnRef idx="1">
+            <a:schemeClr val="accent1"/>
+          </a:lnRef>
+          <a:fillRef idx="3">
+            <a:schemeClr val="accent1"/>
+          </a:fillRef>
+          <a:effectRef idx="2">
+            <a:schemeClr val="accent1"/>
+          </a:effectRef>
+          <a:fontRef idx="minor">
+            <a:schemeClr val="lt1"/>
+          </a:fontRef>
+        </p:style>
+        <p:txBody>
+          <a:bodyPr rtlCol="0" anchor="ctr" wrap="square" lIns="27432" tIns="21945" rIns="27432" bIns="21945">
+            <a:noAutofit/>
+          </a:bodyPr>
+          <a:lstStyle/>
+          <a:p>
+            <a:pPr algn="ctr">
+              <a:spcBef>
+                <a:spcPts val="0"/>
+              </a:spcBef>
+              <a:spcAft>
+                <a:spcPts val="0"/>
+              </a:spcAft>
+            </a:pPr>
+            <a:r>
+              <a:rPr sz="950" b="1" i="0" lang="en-GB">
+                <a:solidFill>
+                  <a:srgbClr val="0E7C7B"/>
+                </a:solidFill>
+                <a:latin typeface="Aptos"/>
+                <a:ea typeface="Aptos"/>
+                <a:cs typeface="Dubai"/>
+              </a:rPr>
+              <a:t>MET</a:t>
+            </a:r>
+          </a:p>
+        </p:txBody>
+      </p:sp>
+      <p:sp>
+        <p:nvSpPr>
+          <p:cNvPr id="37" name="TextBox 36"/>
+          <p:cNvSpPr txBox="1"/>
+          <p:nvPr/>
+        </p:nvSpPr>
+        <p:spPr>
+          <a:xfrm>
+            <a:off x="4585716" y="4169663"/>
+            <a:ext cx="3108960" cy="438912"/>
+          </a:xfrm>
+          <a:prstGeom prst="rect">
+            <a:avLst/>
+          </a:prstGeom>
+          <a:noFill/>
+        </p:spPr>
+        <p:txBody>
+          <a:bodyPr wrap="square" lIns="0" tIns="0" rIns="0" bIns="0" anchor="t">
+            <a:noAutofit/>
+          </a:bodyPr>
+          <a:lstStyle/>
+          <a:p>
+            <a:pPr algn="l">
+              <a:lnSpc>
+                <a:spcPct val="95000"/>
+              </a:lnSpc>
+              <a:spcBef>
+                <a:spcPts val="0"/>
+              </a:spcBef>
+              <a:spcAft>
+                <a:spcPts val="0"/>
+              </a:spcAft>
+            </a:pPr>
+            <a:r>
+              <a:rPr sz="1200" b="0" i="0" lang="en-GB">
+                <a:solidFill>
+                  <a:srgbClr val="5B6573"/>
+                </a:solidFill>
+                <a:latin typeface="Aptos"/>
+                <a:ea typeface="Aptos"/>
+                <a:cs typeface="Dubai"/>
+              </a:rPr>
+              <a:t>until results appear; double-checks fill in after</a:t>
+            </a:r>
+          </a:p>
+        </p:txBody>
+      </p:sp>
+      <p:sp>
+        <p:nvSpPr>
+          <p:cNvPr id="38" name="TextBox 37"/>
+          <p:cNvSpPr txBox="1"/>
+          <p:nvPr/>
+        </p:nvSpPr>
+        <p:spPr>
+          <a:xfrm>
+            <a:off x="4585716" y="4608576"/>
+            <a:ext cx="3108960" cy="640080"/>
+          </a:xfrm>
+          <a:prstGeom prst="rect">
+            <a:avLst/>
+          </a:prstGeom>
+          <a:noFill/>
+        </p:spPr>
+        <p:txBody>
+          <a:bodyPr wrap="square" lIns="0" tIns="0" rIns="0" bIns="0" anchor="t">
+            <a:noAutofit/>
+          </a:bodyPr>
+          <a:lstStyle/>
+          <a:p>
+            <a:pPr algn="l">
+              <a:lnSpc>
+                <a:spcPct val="95000"/>
+              </a:lnSpc>
+              <a:spcBef>
+                <a:spcPts val="0"/>
+              </a:spcBef>
+              <a:spcAft>
+                <a:spcPts val="0"/>
+              </a:spcAft>
+            </a:pPr>
+            <a:r>
+              <a:rPr sz="1250" b="1" i="0" lang="en-GB">
+                <a:solidFill>
+                  <a:srgbClr val="0E7C7B"/>
+                </a:solidFill>
+                <a:latin typeface="Aptos"/>
+                <a:ea typeface="Aptos"/>
+                <a:cs typeface="Dubai"/>
+              </a:rPr>
+              <a:t>Measured: </a:t>
+            </a:r>
+            <a:r>
+              <a:rPr sz="1250" b="0" i="0" lang="en-GB">
+                <a:solidFill>
+                  <a:srgbClr val="1F2937"/>
+                </a:solidFill>
+                <a:latin typeface="Aptos"/>
+                <a:ea typeface="Aptos"/>
+                <a:cs typeface="Dubai"/>
+              </a:rPr>
+              <a:t>2.1 s median, under 5 s for 112 of 113 searches. The double-check adds about 17 s.</a:t>
+            </a:r>
+          </a:p>
+        </p:txBody>
+      </p:sp>
+      <p:sp>
+        <p:nvSpPr>
+          <p:cNvPr id="39" name="Rounded Rectangle 38"/>
+          <p:cNvSpPr/>
+          <p:nvPr/>
+        </p:nvSpPr>
+        <p:spPr>
+          <a:xfrm>
+            <a:off x="8074152" y="3602736"/>
+            <a:ext cx="3566160" cy="1719072"/>
+          </a:xfrm>
+          <a:prstGeom prst="roundRect">
+            <a:avLst>
+              <a:gd name="adj" fmla="val 6000"/>
+            </a:avLst>
+          </a:prstGeom>
+          <a:solidFill>
+            <a:srgbClr val="F3F5F7"/>
+          </a:solidFill>
+          <a:ln>
+            <a:noFill/>
+          </a:ln>
+          <a:effectLst/>
+        </p:spPr>
+        <p:style>
+          <a:lnRef idx="1">
+            <a:schemeClr val="accent1"/>
+          </a:lnRef>
+          <a:fillRef idx="3">
+            <a:schemeClr val="accent1"/>
+          </a:fillRef>
+          <a:effectRef idx="2">
+            <a:schemeClr val="accent1"/>
+          </a:effectRef>
+          <a:fontRef idx="minor">
+            <a:schemeClr val="lt1"/>
+          </a:fontRef>
+        </p:style>
+        <p:txBody>
+          <a:bodyPr rtlCol="0" anchor="ctr"/>
+          <a:lstStyle/>
+          <a:p>
+            <a:pPr algn="ctr"/>
+          </a:p>
+        </p:txBody>
+      </p:sp>
+      <p:sp>
+        <p:nvSpPr>
+          <p:cNvPr id="40" name="Rectangle 39"/>
+          <p:cNvSpPr/>
+          <p:nvPr/>
+        </p:nvSpPr>
+        <p:spPr>
+          <a:xfrm>
+            <a:off x="8074152" y="3785615"/>
+            <a:ext cx="64008" cy="1353312"/>
+          </a:xfrm>
+          <a:prstGeom prst="rect">
+            <a:avLst/>
+          </a:prstGeom>
+          <a:solidFill>
+            <a:srgbClr val="5B6573"/>
+          </a:solidFill>
+          <a:ln>
+            <a:noFill/>
+          </a:ln>
+          <a:effectLst/>
+        </p:spPr>
+        <p:style>
+          <a:lnRef idx="1">
+            <a:schemeClr val="accent1"/>
+          </a:lnRef>
+          <a:fillRef idx="3">
+            <a:schemeClr val="accent1"/>
+          </a:fillRef>
+          <a:effectRef idx="2">
+            <a:schemeClr val="accent1"/>
+          </a:effectRef>
+          <a:fontRef idx="minor">
+            <a:schemeClr val="lt1"/>
+          </a:fontRef>
+        </p:style>
+        <p:txBody>
+          <a:bodyPr rtlCol="0" anchor="ctr"/>
+          <a:lstStyle/>
+          <a:p>
+            <a:pPr algn="ctr"/>
+          </a:p>
+        </p:txBody>
+      </p:sp>
+      <p:sp>
+        <p:nvSpPr>
+          <p:cNvPr id="41" name="TextBox 40"/>
+          <p:cNvSpPr txBox="1"/>
+          <p:nvPr/>
+        </p:nvSpPr>
+        <p:spPr>
+          <a:xfrm>
+            <a:off x="8348472" y="3730752"/>
+            <a:ext cx="2011680" cy="457200"/>
+          </a:xfrm>
+          <a:prstGeom prst="rect">
+            <a:avLst/>
+          </a:prstGeom>
+          <a:noFill/>
+        </p:spPr>
+        <p:txBody>
+          <a:bodyPr wrap="square" lIns="0" tIns="0" rIns="0" bIns="0" anchor="t">
+            <a:noAutofit/>
+          </a:bodyPr>
+          <a:lstStyle/>
+          <a:p>
+            <a:pPr algn="l">
+              <a:spcBef>
+                <a:spcPts val="0"/>
+              </a:spcBef>
+              <a:spcAft>
+                <a:spcPts val="0"/>
+              </a:spcAft>
+            </a:pPr>
+            <a:r>
+              <a:rPr sz="2600" b="1" i="0" lang="en-GB">
+                <a:solidFill>
+                  <a:srgbClr val="0F2A44"/>
+                </a:solidFill>
+                <a:latin typeface="Aptos"/>
+                <a:ea typeface="Aptos"/>
+                <a:cs typeface="Dubai"/>
+              </a:rPr>
+              <a:t>&lt; 2 min</a:t>
+            </a:r>
+          </a:p>
+        </p:txBody>
+      </p:sp>
+      <p:sp>
+        <p:nvSpPr>
+          <p:cNvPr id="42" name="Rounded Rectangle 41"/>
+          <p:cNvSpPr/>
+          <p:nvPr/>
+        </p:nvSpPr>
+        <p:spPr>
+          <a:xfrm>
+            <a:off x="10131552" y="3785615"/>
+            <a:ext cx="1325880" cy="274320"/>
+          </a:xfrm>
+          <a:prstGeom prst="roundRect">
+            <a:avLst>
+              <a:gd name="adj" fmla="val 50000"/>
+            </a:avLst>
+          </a:prstGeom>
+          <a:solidFill>
+            <a:srgbClr val="E4E9EF"/>
+          </a:solidFill>
+          <a:ln w="12700">
+            <a:solidFill>
+              <a:srgbClr val="5B6573"/>
+            </a:solidFill>
+          </a:ln>
+          <a:effectLst/>
+        </p:spPr>
+        <p:style>
+          <a:lnRef idx="1">
+            <a:schemeClr val="accent1"/>
+          </a:lnRef>
+          <a:fillRef idx="3">
+            <a:schemeClr val="accent1"/>
+          </a:fillRef>
+          <a:effectRef idx="2">
+            <a:schemeClr val="accent1"/>
+          </a:effectRef>
+          <a:fontRef idx="minor">
+            <a:schemeClr val="lt1"/>
+          </a:fontRef>
+        </p:style>
+        <p:txBody>
+          <a:bodyPr rtlCol="0" anchor="ctr" wrap="square" lIns="27432" tIns="21945" rIns="27432" bIns="21945">
+            <a:noAutofit/>
+          </a:bodyPr>
+          <a:lstStyle/>
+          <a:p>
+            <a:pPr algn="ctr">
+              <a:spcBef>
+                <a:spcPts val="0"/>
+              </a:spcBef>
+              <a:spcAft>
+                <a:spcPts val="0"/>
+              </a:spcAft>
+            </a:pPr>
+            <a:r>
+              <a:rPr sz="950" b="1" i="0" lang="en-GB">
+                <a:solidFill>
+                  <a:srgbClr val="5B6573"/>
+                </a:solidFill>
+                <a:latin typeface="Aptos"/>
+                <a:ea typeface="Aptos"/>
+                <a:cs typeface="Dubai"/>
+              </a:rPr>
+              <a:t>NOT MEASURED</a:t>
+            </a:r>
+          </a:p>
+        </p:txBody>
+      </p:sp>
+      <p:sp>
+        <p:nvSpPr>
+          <p:cNvPr id="43" name="TextBox 42"/>
+          <p:cNvSpPr txBox="1"/>
+          <p:nvPr/>
+        </p:nvSpPr>
+        <p:spPr>
+          <a:xfrm>
+            <a:off x="8348472" y="4169663"/>
+            <a:ext cx="3108960" cy="438912"/>
+          </a:xfrm>
+          <a:prstGeom prst="rect">
+            <a:avLst/>
+          </a:prstGeom>
+          <a:noFill/>
+        </p:spPr>
+        <p:txBody>
+          <a:bodyPr wrap="square" lIns="0" tIns="0" rIns="0" bIns="0" anchor="t">
+            <a:noAutofit/>
+          </a:bodyPr>
+          <a:lstStyle/>
+          <a:p>
+            <a:pPr algn="l">
+              <a:lnSpc>
+                <a:spcPct val="95000"/>
+              </a:lnSpc>
+              <a:spcBef>
+                <a:spcPts val="0"/>
+              </a:spcBef>
+              <a:spcAft>
+                <a:spcPts val="0"/>
+              </a:spcAft>
+            </a:pPr>
+            <a:r>
+              <a:rPr sz="1200" b="0" i="0" lang="en-GB">
+                <a:solidFill>
+                  <a:srgbClr val="5B6573"/>
+                </a:solidFill>
+                <a:latin typeface="Aptos"/>
+                <a:ea typeface="Aptos"/>
+                <a:cs typeface="Dubai"/>
+              </a:rPr>
+              <a:t>for an officer to find the target of each story</a:t>
+            </a:r>
+          </a:p>
+        </p:txBody>
+      </p:sp>
+      <p:sp>
+        <p:nvSpPr>
+          <p:cNvPr id="44" name="TextBox 43"/>
+          <p:cNvSpPr txBox="1"/>
+          <p:nvPr/>
+        </p:nvSpPr>
+        <p:spPr>
+          <a:xfrm>
+            <a:off x="8348472" y="4608576"/>
+            <a:ext cx="3108960" cy="640080"/>
+          </a:xfrm>
+          <a:prstGeom prst="rect">
+            <a:avLst/>
+          </a:prstGeom>
+          <a:noFill/>
+        </p:spPr>
+        <p:txBody>
+          <a:bodyPr wrap="square" lIns="0" tIns="0" rIns="0" bIns="0" anchor="t">
+            <a:noAutofit/>
+          </a:bodyPr>
+          <a:lstStyle/>
+          <a:p>
+            <a:pPr algn="l">
+              <a:lnSpc>
+                <a:spcPct val="95000"/>
+              </a:lnSpc>
+              <a:spcBef>
+                <a:spcPts val="0"/>
+              </a:spcBef>
+              <a:spcAft>
+                <a:spcPts val="0"/>
+              </a:spcAft>
+            </a:pPr>
+            <a:r>
+              <a:rPr sz="1250" b="1" i="0" lang="en-GB">
+                <a:solidFill>
+                  <a:srgbClr val="5B6573"/>
+                </a:solidFill>
+                <a:latin typeface="Aptos"/>
+                <a:ea typeface="Aptos"/>
+                <a:cs typeface="Dubai"/>
+              </a:rPr>
+              <a:t>Measured: </a:t>
+            </a:r>
+            <a:r>
+              <a:rPr sz="1250" b="0" i="0" lang="en-GB">
+                <a:solidFill>
+                  <a:srgbClr val="1F2937"/>
+                </a:solidFill>
+                <a:latin typeface="Aptos"/>
+                <a:ea typeface="Aptos"/>
+                <a:cs typeface="Dubai"/>
+              </a:rPr>
+              <a:t>not yet; phase 2 had no timed run with an officer.</a:t>
+            </a:r>
+          </a:p>
+        </p:txBody>
+      </p:sp>
+      <p:sp>
+        <p:nvSpPr>
+          <p:cNvPr id="45" name="Rounded Rectangle 44"/>
+          <p:cNvSpPr/>
+          <p:nvPr/>
+        </p:nvSpPr>
+        <p:spPr>
+          <a:xfrm>
+            <a:off x="548640" y="5440680"/>
+            <a:ext cx="11091672" cy="804672"/>
           </a:xfrm>
           <a:prstGeom prst="roundRect">
             <a:avLst>
@@ -13995,7 +13504,7 @@
             </a:avLst>
           </a:prstGeom>
           <a:solidFill>
-            <a:srgbClr val="E3F2F1"/>
+            <a:srgbClr val="FDF1E1"/>
           </a:solidFill>
           <a:ln>
             <a:noFill/>
@@ -14017,7 +13526,7 @@
           </a:fontRef>
         </p:style>
         <p:txBody>
-          <a:bodyPr rtlCol="0" anchor="ctr" wrap="square" lIns="164592" tIns="131673" rIns="164592" bIns="131673">
+          <a:bodyPr rtlCol="0" anchor="ctr" wrap="square" lIns="201168" tIns="160934" rIns="201168" bIns="160934">
             <a:noAutofit/>
           </a:bodyPr>
           <a:lstStyle/>
@@ -14027,32 +13536,22 @@
                 <a:spcPts val="0"/>
               </a:spcBef>
               <a:spcAft>
-                <a:spcPts val="200"/>
+                <a:spcPts val="0"/>
               </a:spcAft>
             </a:pPr>
             <a:r>
-              <a:rPr sz="1500" b="1" i="0" lang="en-GB">
-                <a:solidFill>
-                  <a:srgbClr val="0E7C7B"/>
-                </a:solidFill>
-                <a:latin typeface="Aptos"/>
-                <a:ea typeface="Aptos"/>
-                <a:cs typeface="Dubai"/>
-              </a:rPr>
-              <a:t>Site pilot</a:t>
-            </a:r>
-          </a:p>
-          <a:p>
-            <a:pPr algn="l">
-              <a:spcBef>
-                <a:spcPts val="0"/>
-              </a:spcBef>
-              <a:spcAft>
-                <a:spcPts val="0"/>
-              </a:spcAft>
-            </a:pPr>
-            <a:r>
-              <a:rPr sz="1250" b="0" i="0" lang="en-GB">
+              <a:rPr sz="1300" b="1" i="0" lang="en-GB">
+                <a:solidFill>
+                  <a:srgbClr val="B45F06"/>
+                </a:solidFill>
+                <a:latin typeface="Aptos"/>
+                <a:ea typeface="Aptos"/>
+                <a:cs typeface="Dubai"/>
+              </a:rPr>
+              <a:t>Main risk: </a:t>
+            </a:r>
+            <a:r>
+              <a:rPr sz="1300" b="0" i="0" lang="en-GB">
                 <a:solidFill>
                   <a:srgbClr val="1F2937"/>
                 </a:solidFill>
@@ -14060,498 +13559,7 @@
                 <a:ea typeface="Aptos"/>
                 <a:cs typeface="Dubai"/>
               </a:rPr>
-              <a:t>One mall, terminal or ministry, with the site as partner</a:t>
-            </a:r>
-          </a:p>
-        </p:txBody>
-      </p:sp>
-      <p:sp>
-        <p:nvSpPr>
-          <p:cNvPr id="26" name="Chevron 25"/>
-          <p:cNvSpPr/>
-          <p:nvPr/>
-        </p:nvSpPr>
-        <p:spPr>
-          <a:xfrm>
-            <a:off x="3246120" y="4544568"/>
-            <a:ext cx="201168" cy="365760"/>
-          </a:xfrm>
-          <a:prstGeom prst="chevron">
-            <a:avLst/>
-          </a:prstGeom>
-          <a:solidFill>
-            <a:srgbClr val="D5DBE1"/>
-          </a:solidFill>
-          <a:ln>
-            <a:noFill/>
-          </a:ln>
-          <a:effectLst/>
-        </p:spPr>
-        <p:style>
-          <a:lnRef idx="1">
-            <a:schemeClr val="accent1"/>
-          </a:lnRef>
-          <a:fillRef idx="3">
-            <a:schemeClr val="accent1"/>
-          </a:fillRef>
-          <a:effectRef idx="2">
-            <a:schemeClr val="accent1"/>
-          </a:effectRef>
-          <a:fontRef idx="minor">
-            <a:schemeClr val="lt1"/>
-          </a:fontRef>
-        </p:style>
-        <p:txBody>
-          <a:bodyPr rtlCol="0" anchor="ctr"/>
-          <a:lstStyle/>
-          <a:p>
-            <a:pPr algn="ctr"/>
-          </a:p>
-        </p:txBody>
-      </p:sp>
-      <p:sp>
-        <p:nvSpPr>
-          <p:cNvPr id="27" name="Rounded Rectangle 26"/>
-          <p:cNvSpPr/>
-          <p:nvPr/>
-        </p:nvSpPr>
-        <p:spPr>
-          <a:xfrm>
-            <a:off x="3538728" y="4251960"/>
-            <a:ext cx="2606040" cy="960120"/>
-          </a:xfrm>
-          <a:prstGeom prst="roundRect">
-            <a:avLst>
-              <a:gd name="adj" fmla="val 8000"/>
-            </a:avLst>
-          </a:prstGeom>
-          <a:solidFill>
-            <a:srgbClr val="F3F5F7"/>
-          </a:solidFill>
-          <a:ln>
-            <a:noFill/>
-          </a:ln>
-          <a:effectLst/>
-        </p:spPr>
-        <p:style>
-          <a:lnRef idx="1">
-            <a:schemeClr val="accent1"/>
-          </a:lnRef>
-          <a:fillRef idx="3">
-            <a:schemeClr val="accent1"/>
-          </a:fillRef>
-          <a:effectRef idx="2">
-            <a:schemeClr val="accent1"/>
-          </a:effectRef>
-          <a:fontRef idx="minor">
-            <a:schemeClr val="lt1"/>
-          </a:fontRef>
-        </p:style>
-        <p:txBody>
-          <a:bodyPr rtlCol="0" anchor="ctr" wrap="square" lIns="164592" tIns="131673" rIns="164592" bIns="131673">
-            <a:noAutofit/>
-          </a:bodyPr>
-          <a:lstStyle/>
-          <a:p>
-            <a:pPr algn="l">
-              <a:spcBef>
-                <a:spcPts val="0"/>
-              </a:spcBef>
-              <a:spcAft>
-                <a:spcPts val="200"/>
-              </a:spcAft>
-            </a:pPr>
-            <a:r>
-              <a:rPr sz="1500" b="1" i="0" lang="en-GB">
-                <a:solidFill>
-                  <a:srgbClr val="B45F06"/>
-                </a:solidFill>
-                <a:latin typeface="Aptos"/>
-                <a:ea typeface="Aptos"/>
-                <a:cs typeface="Dubai"/>
-              </a:rPr>
-              <a:t>District</a:t>
-            </a:r>
-          </a:p>
-          <a:p>
-            <a:pPr algn="l">
-              <a:spcBef>
-                <a:spcPts val="0"/>
-              </a:spcBef>
-              <a:spcAft>
-                <a:spcPts val="0"/>
-              </a:spcAft>
-            </a:pPr>
-            <a:r>
-              <a:rPr sz="1250" b="0" i="0" lang="en-GB">
-                <a:solidFill>
-                  <a:srgbClr val="1F2937"/>
-                </a:solidFill>
-                <a:latin typeface="Aptos"/>
-                <a:ea typeface="Aptos"/>
-                <a:cs typeface="Dubai"/>
-              </a:rPr>
-              <a:t>Needs a public-sector sponsor</a:t>
-            </a:r>
-          </a:p>
-        </p:txBody>
-      </p:sp>
-      <p:sp>
-        <p:nvSpPr>
-          <p:cNvPr id="28" name="Chevron 27"/>
-          <p:cNvSpPr/>
-          <p:nvPr/>
-        </p:nvSpPr>
-        <p:spPr>
-          <a:xfrm>
-            <a:off x="6236208" y="4544568"/>
-            <a:ext cx="201168" cy="365760"/>
-          </a:xfrm>
-          <a:prstGeom prst="chevron">
-            <a:avLst/>
-          </a:prstGeom>
-          <a:solidFill>
-            <a:srgbClr val="D5DBE1"/>
-          </a:solidFill>
-          <a:ln>
-            <a:noFill/>
-          </a:ln>
-          <a:effectLst/>
-        </p:spPr>
-        <p:style>
-          <a:lnRef idx="1">
-            <a:schemeClr val="accent1"/>
-          </a:lnRef>
-          <a:fillRef idx="3">
-            <a:schemeClr val="accent1"/>
-          </a:fillRef>
-          <a:effectRef idx="2">
-            <a:schemeClr val="accent1"/>
-          </a:effectRef>
-          <a:fontRef idx="minor">
-            <a:schemeClr val="lt1"/>
-          </a:fontRef>
-        </p:style>
-        <p:txBody>
-          <a:bodyPr rtlCol="0" anchor="ctr"/>
-          <a:lstStyle/>
-          <a:p>
-            <a:pPr algn="ctr"/>
-          </a:p>
-        </p:txBody>
-      </p:sp>
-      <p:sp>
-        <p:nvSpPr>
-          <p:cNvPr id="29" name="Rounded Rectangle 28"/>
-          <p:cNvSpPr/>
-          <p:nvPr/>
-        </p:nvSpPr>
-        <p:spPr>
-          <a:xfrm>
-            <a:off x="6528816" y="4251960"/>
-            <a:ext cx="2606040" cy="960120"/>
-          </a:xfrm>
-          <a:prstGeom prst="roundRect">
-            <a:avLst>
-              <a:gd name="adj" fmla="val 8000"/>
-            </a:avLst>
-          </a:prstGeom>
-          <a:solidFill>
-            <a:srgbClr val="F3F5F7"/>
-          </a:solidFill>
-          <a:ln>
-            <a:noFill/>
-          </a:ln>
-          <a:effectLst/>
-        </p:spPr>
-        <p:style>
-          <a:lnRef idx="1">
-            <a:schemeClr val="accent1"/>
-          </a:lnRef>
-          <a:fillRef idx="3">
-            <a:schemeClr val="accent1"/>
-          </a:fillRef>
-          <a:effectRef idx="2">
-            <a:schemeClr val="accent1"/>
-          </a:effectRef>
-          <a:fontRef idx="minor">
-            <a:schemeClr val="lt1"/>
-          </a:fontRef>
-        </p:style>
-        <p:txBody>
-          <a:bodyPr rtlCol="0" anchor="ctr" wrap="square" lIns="164592" tIns="131673" rIns="164592" bIns="131673">
-            <a:noAutofit/>
-          </a:bodyPr>
-          <a:lstStyle/>
-          <a:p>
-            <a:pPr algn="l">
-              <a:spcBef>
-                <a:spcPts val="0"/>
-              </a:spcBef>
-              <a:spcAft>
-                <a:spcPts val="200"/>
-              </a:spcAft>
-            </a:pPr>
-            <a:r>
-              <a:rPr sz="1500" b="1" i="0" lang="en-GB">
-                <a:solidFill>
-                  <a:srgbClr val="0F2A44"/>
-                </a:solidFill>
-                <a:latin typeface="Aptos"/>
-                <a:ea typeface="Aptos"/>
-                <a:cs typeface="Dubai"/>
-              </a:rPr>
-              <a:t>City programme</a:t>
-            </a:r>
-          </a:p>
-          <a:p>
-            <a:pPr algn="l">
-              <a:spcBef>
-                <a:spcPts val="0"/>
-              </a:spcBef>
-              <a:spcAft>
-                <a:spcPts val="0"/>
-              </a:spcAft>
-            </a:pPr>
-            <a:r>
-              <a:rPr sz="1250" b="0" i="0" lang="en-GB">
-                <a:solidFill>
-                  <a:srgbClr val="1F2937"/>
-                </a:solidFill>
-                <a:latin typeface="Aptos"/>
-                <a:ea typeface="Aptos"/>
-                <a:cs typeface="Dubai"/>
-              </a:rPr>
-              <a:t>Our search layer plugs in</a:t>
-            </a:r>
-          </a:p>
-        </p:txBody>
-      </p:sp>
-      <p:sp>
-        <p:nvSpPr>
-          <p:cNvPr id="30" name="Rounded Rectangle 29"/>
-          <p:cNvSpPr/>
-          <p:nvPr/>
-        </p:nvSpPr>
-        <p:spPr>
-          <a:xfrm>
-            <a:off x="9281160" y="3931920"/>
-            <a:ext cx="2359152" cy="2286000"/>
-          </a:xfrm>
-          <a:prstGeom prst="roundRect">
-            <a:avLst>
-              <a:gd name="adj" fmla="val 6000"/>
-            </a:avLst>
-          </a:prstGeom>
-          <a:solidFill>
-            <a:srgbClr val="0F2A44"/>
-          </a:solidFill>
-          <a:ln>
-            <a:noFill/>
-          </a:ln>
-          <a:effectLst/>
-        </p:spPr>
-        <p:style>
-          <a:lnRef idx="1">
-            <a:schemeClr val="accent1"/>
-          </a:lnRef>
-          <a:fillRef idx="3">
-            <a:schemeClr val="accent1"/>
-          </a:fillRef>
-          <a:effectRef idx="2">
-            <a:schemeClr val="accent1"/>
-          </a:effectRef>
-          <a:fontRef idx="minor">
-            <a:schemeClr val="lt1"/>
-          </a:fontRef>
-        </p:style>
-        <p:txBody>
-          <a:bodyPr rtlCol="0" anchor="ctr" wrap="square" lIns="182880" tIns="146304" rIns="182880" bIns="146304">
-            <a:noAutofit/>
-          </a:bodyPr>
-          <a:lstStyle/>
-          <a:p>
-            <a:pPr algn="l">
-              <a:spcBef>
-                <a:spcPts val="0"/>
-              </a:spcBef>
-              <a:spcAft>
-                <a:spcPts val="600"/>
-              </a:spcAft>
-            </a:pPr>
-            <a:r>
-              <a:rPr sz="1100" b="1" i="0" lang="en-GB">
-                <a:solidFill>
-                  <a:srgbClr val="7FD1CC"/>
-                </a:solidFill>
-                <a:latin typeface="Aptos"/>
-                <a:ea typeface="Aptos"/>
-                <a:cs typeface="Dubai"/>
-              </a:rPr>
-              <a:t>TEAM</a:t>
-            </a:r>
-          </a:p>
-          <a:p>
-            <a:pPr algn="l">
-              <a:spcBef>
-                <a:spcPts val="0"/>
-              </a:spcBef>
-              <a:spcAft>
-                <a:spcPts val="600"/>
-              </a:spcAft>
-            </a:pPr>
-            <a:r>
-              <a:rPr sz="1300" b="0" i="0" lang="en-GB">
-                <a:solidFill>
-                  <a:srgbClr val="FFFFFF"/>
-                </a:solidFill>
-                <a:latin typeface="Aptos"/>
-                <a:ea typeface="Aptos"/>
-                <a:cs typeface="Dubai"/>
-              </a:rPr>
-              <a:t>1 computer-vision engineer</a:t>
-            </a:r>
-          </a:p>
-          <a:p>
-            <a:pPr algn="l">
-              <a:spcBef>
-                <a:spcPts val="0"/>
-              </a:spcBef>
-              <a:spcAft>
-                <a:spcPts val="600"/>
-              </a:spcAft>
-            </a:pPr>
-            <a:r>
-              <a:rPr sz="1300" b="0" i="0" lang="en-GB">
-                <a:solidFill>
-                  <a:srgbClr val="FFFFFF"/>
-                </a:solidFill>
-                <a:latin typeface="Aptos"/>
-                <a:ea typeface="Aptos"/>
-                <a:cs typeface="Dubai"/>
-              </a:rPr>
-              <a:t>1 full-stack engineer</a:t>
-            </a:r>
-          </a:p>
-          <a:p>
-            <a:pPr algn="l">
-              <a:spcBef>
-                <a:spcPts val="0"/>
-              </a:spcBef>
-              <a:spcAft>
-                <a:spcPts val="600"/>
-              </a:spcAft>
-            </a:pPr>
-            <a:r>
-              <a:rPr sz="1300" b="0" i="0" lang="en-GB">
-                <a:solidFill>
-                  <a:srgbClr val="FFFFFF"/>
-                </a:solidFill>
-                <a:latin typeface="Aptos"/>
-                <a:ea typeface="Aptos"/>
-                <a:cs typeface="Dubai"/>
-              </a:rPr>
-              <a:t>Part-time native Arabic speaker</a:t>
-            </a:r>
-          </a:p>
-          <a:p>
-            <a:pPr algn="l">
-              <a:spcBef>
-                <a:spcPts val="0"/>
-              </a:spcBef>
-              <a:spcAft>
-                <a:spcPts val="0"/>
-              </a:spcAft>
-            </a:pPr>
-            <a:r>
-              <a:rPr sz="1300" b="0" i="0" lang="en-GB">
-                <a:solidFill>
-                  <a:srgbClr val="FFFFFF"/>
-                </a:solidFill>
-                <a:latin typeface="Aptos"/>
-                <a:ea typeface="Aptos"/>
-                <a:cs typeface="Dubai"/>
-              </a:rPr>
-              <a:t>Part-time PM and legal</a:t>
-            </a:r>
-          </a:p>
-        </p:txBody>
-      </p:sp>
-      <p:sp>
-        <p:nvSpPr>
-          <p:cNvPr id="31" name="Rounded Rectangle 30"/>
-          <p:cNvSpPr/>
-          <p:nvPr/>
-        </p:nvSpPr>
-        <p:spPr>
-          <a:xfrm>
-            <a:off x="548640" y="5440680"/>
-            <a:ext cx="8513064" cy="777240"/>
-          </a:xfrm>
-          <a:prstGeom prst="roundRect">
-            <a:avLst>
-              <a:gd name="adj" fmla="val 8000"/>
-            </a:avLst>
-          </a:prstGeom>
-          <a:solidFill>
-            <a:srgbClr val="FFFFFF"/>
-          </a:solidFill>
-          <a:ln w="12700">
-            <a:solidFill>
-              <a:srgbClr val="D5DBE1"/>
-            </a:solidFill>
-          </a:ln>
-          <a:effectLst/>
-        </p:spPr>
-        <p:style>
-          <a:lnRef idx="1">
-            <a:schemeClr val="accent1"/>
-          </a:lnRef>
-          <a:fillRef idx="3">
-            <a:schemeClr val="accent1"/>
-          </a:fillRef>
-          <a:effectRef idx="2">
-            <a:schemeClr val="accent1"/>
-          </a:effectRef>
-          <a:fontRef idx="minor">
-            <a:schemeClr val="lt1"/>
-          </a:fontRef>
-        </p:style>
-        <p:txBody>
-          <a:bodyPr rtlCol="0" anchor="ctr" wrap="square" lIns="182880" tIns="146304" rIns="182880" bIns="146304">
-            <a:noAutofit/>
-          </a:bodyPr>
-          <a:lstStyle/>
-          <a:p>
-            <a:pPr algn="l">
-              <a:spcBef>
-                <a:spcPts val="0"/>
-              </a:spcBef>
-              <a:spcAft>
-                <a:spcPts val="0"/>
-              </a:spcAft>
-            </a:pPr>
-            <a:r>
-              <a:rPr sz="1350" b="1" i="0" lang="en-GB">
-                <a:solidFill>
-                  <a:srgbClr val="0F2A44"/>
-                </a:solidFill>
-                <a:latin typeface="Aptos"/>
-                <a:ea typeface="Aptos"/>
-                <a:cs typeface="Dubai"/>
-              </a:rPr>
-              <a:t>Already settled: </a:t>
-            </a:r>
-            <a:r>
-              <a:rPr sz="1350" b="0" i="0" lang="en-GB">
-                <a:solidFill>
-                  <a:srgbClr val="1F2937"/>
-                </a:solidFill>
-                <a:latin typeface="Aptos"/>
-                <a:ea typeface="Aptos"/>
-                <a:cs typeface="Dubai"/>
-              </a:rPr>
-              <a:t>appearance search only, local models only, recorded footage only, all three stories in the demo, and the demo on one Mac.</a:t>
+              <a:t>no public test exists for Jordanian or Gulf Arabic against video, so the 113 test queries are our own. Settings were tuned on the first 48; the 63 written later are the fairer check (98% top 10, option A 95%).</a:t>
             </a:r>
           </a:p>
         </p:txBody>
@@ -14730,7 +13738,7 @@
                 <a:ea typeface="Aptos"/>
                 <a:cs typeface="Dubai"/>
               </a:rPr>
-              <a:t>2 / 13</a:t>
+              <a:t>2 / 12</a:t>
             </a:r>
           </a:p>
         </p:txBody>
@@ -19107,7 +18115,7 @@
                 <a:ea typeface="Aptos"/>
                 <a:cs typeface="Dubai"/>
               </a:rPr>
-              <a:t>3 / 13</a:t>
+              <a:t>3 / 12</a:t>
             </a:r>
           </a:p>
         </p:txBody>
@@ -22160,7 +21168,7 @@
                 <a:ea typeface="Aptos"/>
                 <a:cs typeface="Dubai"/>
               </a:rPr>
-              <a:t>4 / 13</a:t>
+              <a:t>4 / 12</a:t>
             </a:r>
           </a:p>
         </p:txBody>
@@ -24590,7 +23598,7 @@
                 <a:ea typeface="Aptos"/>
                 <a:cs typeface="Dubai"/>
               </a:rPr>
-              <a:t>5 / 13</a:t>
+              <a:t>5 / 12</a:t>
             </a:r>
           </a:p>
         </p:txBody>
@@ -27215,7 +26223,7 @@
                 <a:ea typeface="Aptos"/>
                 <a:cs typeface="Dubai"/>
               </a:rPr>
-              <a:t>6 / 13</a:t>
+              <a:t>6 / 12</a:t>
             </a:r>
           </a:p>
         </p:txBody>
@@ -29678,7 +28686,7 @@
                 <a:ea typeface="Aptos"/>
                 <a:cs typeface="Dubai"/>
               </a:rPr>
-              <a:t>7 / 13</a:t>
+              <a:t>7 / 12</a:t>
             </a:r>
           </a:p>
         </p:txBody>
@@ -31470,7 +30478,7 @@
                 <a:ea typeface="Aptos"/>
                 <a:cs typeface="Dubai"/>
               </a:rPr>
-              <a:t>8 / 13</a:t>
+              <a:t>8 / 12</a:t>
             </a:r>
           </a:p>
         </p:txBody>
@@ -33376,7 +32384,7 @@
                 <a:ea typeface="Aptos"/>
                 <a:cs typeface="Dubai"/>
               </a:rPr>
-              <a:t>9 / 13</a:t>
+              <a:t>9 / 12</a:t>
             </a:r>
           </a:p>
         </p:txBody>
@@ -33973,7 +32981,7 @@
                 <a:ea typeface="Aptos"/>
                 <a:cs typeface="Dubai"/>
               </a:rPr>
-              <a:t>This plan, on one Mac</a:t>
+              <a:t>This plan, on one computer</a:t>
             </a:r>
           </a:p>
         </p:txBody>

</xml_diff>

<commit_message>
docs: say the demo runs as native processes on the deck's demo slide
The PoC as built runs every service as a native process started by
scripts, with no containers, so slide 11 and its notes now say so.
</commit_message>
<xml_diff>
--- a/docs/deck/arabic-video-search-use-cases.pptx
+++ b/docs/deck/arabic-video-search-use-cases.pptx
@@ -715,7 +715,7 @@
           </a:p>
           <a:p>
             <a:r>
-              <a:t>Where it runs (D3): one local computer. App services in Docker; the models run directly on the computer, because Docker containers there cannot use its GPU.</a:t>
+              <a:t>Where it runs (D3): one local computer, with no containers. The app and the AI models all run as native processes, started by plain scripts, so the models can use the computer's GPU.</a:t>
             </a:r>
           </a:p>
           <a:p>
@@ -11282,7 +11282,7 @@
                 <a:ea typeface="Aptos"/>
                 <a:cs typeface="Dubai"/>
               </a:rPr>
-              <a:t>the app in Docker, the AI models on the computer itself. Recorded clips from public datasets, no live cameras, and no cloud AI.</a:t>
+              <a:t>the app and the AI models all run as native processes, with no containers. Recorded clips from public datasets, no live cameras, and no cloud AI.</a:t>
             </a:r>
           </a:p>
         </p:txBody>

</xml_diff>